<commit_message>
Parking lot occupancy detector — PUCPR and UFPR04 complete
</commit_message>
<xml_diff>
--- a/docs/slides.pptx
+++ b/docs/slides.pptx
@@ -15,6 +15,9 @@
     <p:sldId id="263" r:id="rId14"/>
     <p:sldId id="264" r:id="rId15"/>
     <p:sldId id="265" r:id="rId16"/>
+    <p:sldId id="266" r:id="rId17"/>
+    <p:sldId id="267" r:id="rId18"/>
+    <p:sldId id="268" r:id="rId19"/>
   </p:sldIdLst>
   <p:sldSz cx="12188952" cy="6858000" type="screen4x3"/>
   <p:notesSz cx="6858000" cy="9144000"/>
@@ -3366,21 +3369,45 @@
                   <a:srgbClr val="FFFFFF"/>
                 </a:solidFill>
               </a:rPr>
-              <a:t>Future Work</a:t>
-            </a:r>
-          </a:p>
-        </p:txBody>
-      </p:sp>
-      <p:sp>
-        <p:nvSpPr>
-          <p:cNvPr id="4" name="TextBox 3"/>
+              <a:t>Result — UFPR04 (Partially Occupied)</a:t>
+            </a:r>
+          </a:p>
+        </p:txBody>
+      </p:sp>
+      <p:pic>
+        <p:nvPicPr>
+          <p:cNvPr id="4" name="Picture 3" descr="result_UFPR2.jpg"/>
+          <p:cNvPicPr>
+            <a:picLocks noChangeAspect="1"/>
+          </p:cNvPicPr>
+          <p:nvPr/>
+        </p:nvPicPr>
+        <p:blipFill>
+          <a:blip r:embed="rId2"/>
+          <a:stretch>
+            <a:fillRect/>
+          </a:stretch>
+        </p:blipFill>
+        <p:spPr>
+          <a:xfrm>
+            <a:off x="2286000" y="1371600"/>
+            <a:ext cx="7315200" cy="4846320"/>
+          </a:xfrm>
+          <a:prstGeom prst="rect">
+            <a:avLst/>
+          </a:prstGeom>
+        </p:spPr>
+      </p:pic>
+      <p:sp>
+        <p:nvSpPr>
+          <p:cNvPr id="5" name="TextBox 4"/>
           <p:cNvSpPr txBox="1"/>
           <p:nvPr/>
         </p:nvSpPr>
         <p:spPr>
           <a:xfrm>
-            <a:off x="365760" y="1417320"/>
-            <a:ext cx="11430000" cy="502920"/>
+            <a:off x="274320" y="6309360"/>
+            <a:ext cx="11612880" cy="457200"/>
           </a:xfrm>
           <a:prstGeom prst="rect">
             <a:avLst/>
@@ -3393,28 +3420,89 @@
           </a:bodyPr>
           <a:lstStyle/>
           <a:p>
-            <a:pPr algn="l"/>
-            <a:r>
-              <a:rPr sz="2200" b="0">
+            <a:pPr algn="ctr"/>
+            <a:r>
+              <a:rPr sz="1600" b="0">
                 <a:solidFill>
                   <a:srgbClr val="444444"/>
                 </a:solidFill>
               </a:rPr>
-              <a:t>  • Complete ROI tracing for UFPR04 and third parking lot — full multi-lot results table</a:t>
-            </a:r>
-          </a:p>
-        </p:txBody>
-      </p:sp>
-      <p:sp>
-        <p:nvSpPr>
-          <p:cNvPr id="5" name="TextBox 4"/>
+              <a:t>UFPR2.jpg  |  Detected: 120 Occupied  /  137 Empty  |  Total spaces: 257</a:t>
+            </a:r>
+          </a:p>
+        </p:txBody>
+      </p:sp>
+    </p:spTree>
+  </p:cSld>
+  <p:clrMapOvr>
+    <a:masterClrMapping/>
+  </p:clrMapOvr>
+</p:sld>
+</file>
+
+<file path=ppt/slides/slide11.xml><?xml version="1.0" encoding="utf-8"?>
+<p:sld xmlns:a="http://schemas.openxmlformats.org/drawingml/2006/main" xmlns:p="http://schemas.openxmlformats.org/presentationml/2006/main" xmlns:r="http://schemas.openxmlformats.org/officeDocument/2006/relationships">
+  <p:cSld>
+    <p:spTree>
+      <p:nvGrpSpPr>
+        <p:cNvPr id="1" name=""/>
+        <p:cNvGrpSpPr/>
+        <p:nvPr/>
+      </p:nvGrpSpPr>
+      <p:grpSpPr/>
+      <p:sp>
+        <p:nvSpPr>
+          <p:cNvPr id="2" name="Rectangle 1"/>
+          <p:cNvSpPr/>
+          <p:nvPr/>
+        </p:nvSpPr>
+        <p:spPr>
+          <a:xfrm>
+            <a:off x="0" y="0"/>
+            <a:ext cx="12188952" cy="1280160"/>
+          </a:xfrm>
+          <a:prstGeom prst="rect">
+            <a:avLst/>
+          </a:prstGeom>
+          <a:solidFill>
+            <a:srgbClr val="1F3864"/>
+          </a:solidFill>
+          <a:ln>
+            <a:noFill/>
+          </a:ln>
+        </p:spPr>
+        <p:style>
+          <a:lnRef idx="1">
+            <a:schemeClr val="accent1"/>
+          </a:lnRef>
+          <a:fillRef idx="3">
+            <a:schemeClr val="accent1"/>
+          </a:fillRef>
+          <a:effectRef idx="2">
+            <a:schemeClr val="accent1"/>
+          </a:effectRef>
+          <a:fontRef idx="minor">
+            <a:schemeClr val="lt1"/>
+          </a:fontRef>
+        </p:style>
+        <p:txBody>
+          <a:bodyPr rtlCol="0" anchor="ctr"/>
+          <a:lstStyle/>
+          <a:p>
+            <a:pPr algn="ctr"/>
+          </a:p>
+        </p:txBody>
+      </p:sp>
+      <p:sp>
+        <p:nvSpPr>
+          <p:cNvPr id="3" name="TextBox 2"/>
           <p:cNvSpPr txBox="1"/>
           <p:nvPr/>
         </p:nvSpPr>
         <p:spPr>
           <a:xfrm>
-            <a:off x="365760" y="1947672"/>
-            <a:ext cx="11430000" cy="502920"/>
+            <a:off x="274320" y="91440"/>
+            <a:ext cx="11612880" cy="731520"/>
           </a:xfrm>
           <a:prstGeom prst="rect">
             <a:avLst/>
@@ -3429,26 +3517,50 @@
           <a:p>
             <a:pPr algn="l"/>
             <a:r>
-              <a:rPr sz="2200" b="0">
-                <a:solidFill>
-                  <a:srgbClr val="444444"/>
-                </a:solidFill>
-              </a:rPr>
-              <a:t>  • Automatic ROI detection via Hough line transform — no manual tracing for new lots</a:t>
-            </a:r>
-          </a:p>
-        </p:txBody>
-      </p:sp>
-      <p:sp>
-        <p:nvSpPr>
-          <p:cNvPr id="6" name="TextBox 5"/>
+              <a:rPr sz="3200" b="1">
+                <a:solidFill>
+                  <a:srgbClr val="FFFFFF"/>
+                </a:solidFill>
+              </a:rPr>
+              <a:t>Result — UFPR04 (Heavily Occupied)</a:t>
+            </a:r>
+          </a:p>
+        </p:txBody>
+      </p:sp>
+      <p:pic>
+        <p:nvPicPr>
+          <p:cNvPr id="4" name="Picture 3" descr="result_UFPR3.jpg"/>
+          <p:cNvPicPr>
+            <a:picLocks noChangeAspect="1"/>
+          </p:cNvPicPr>
+          <p:nvPr/>
+        </p:nvPicPr>
+        <p:blipFill>
+          <a:blip r:embed="rId2"/>
+          <a:stretch>
+            <a:fillRect/>
+          </a:stretch>
+        </p:blipFill>
+        <p:spPr>
+          <a:xfrm>
+            <a:off x="2286000" y="1371600"/>
+            <a:ext cx="7315200" cy="4846320"/>
+          </a:xfrm>
+          <a:prstGeom prst="rect">
+            <a:avLst/>
+          </a:prstGeom>
+        </p:spPr>
+      </p:pic>
+      <p:sp>
+        <p:nvSpPr>
+          <p:cNvPr id="5" name="TextBox 4"/>
           <p:cNvSpPr txBox="1"/>
           <p:nvPr/>
         </p:nvSpPr>
         <p:spPr>
           <a:xfrm>
-            <a:off x="365760" y="2478024"/>
-            <a:ext cx="11430000" cy="502920"/>
+            <a:off x="274320" y="6309360"/>
+            <a:ext cx="11612880" cy="457200"/>
           </a:xfrm>
           <a:prstGeom prst="rect">
             <a:avLst/>
@@ -3461,28 +3573,89 @@
           </a:bodyPr>
           <a:lstStyle/>
           <a:p>
-            <a:pPr algn="l"/>
-            <a:r>
-              <a:rPr sz="2200" b="0">
+            <a:pPr algn="ctr"/>
+            <a:r>
+              <a:rPr sz="1600" b="0">
                 <a:solidFill>
                   <a:srgbClr val="444444"/>
                 </a:solidFill>
               </a:rPr>
-              <a:t>  • Background subtraction using registered empty-lot reference — eliminate shadow false positives</a:t>
-            </a:r>
-          </a:p>
-        </p:txBody>
-      </p:sp>
-      <p:sp>
-        <p:nvSpPr>
-          <p:cNvPr id="7" name="TextBox 6"/>
+              <a:t>UFPR3.jpg  |  Detected: 212 Occupied  /  45 Empty  |  Total spaces: 257</a:t>
+            </a:r>
+          </a:p>
+        </p:txBody>
+      </p:sp>
+    </p:spTree>
+  </p:cSld>
+  <p:clrMapOvr>
+    <a:masterClrMapping/>
+  </p:clrMapOvr>
+</p:sld>
+</file>
+
+<file path=ppt/slides/slide12.xml><?xml version="1.0" encoding="utf-8"?>
+<p:sld xmlns:a="http://schemas.openxmlformats.org/drawingml/2006/main" xmlns:p="http://schemas.openxmlformats.org/presentationml/2006/main" xmlns:r="http://schemas.openxmlformats.org/officeDocument/2006/relationships">
+  <p:cSld>
+    <p:spTree>
+      <p:nvGrpSpPr>
+        <p:cNvPr id="1" name=""/>
+        <p:cNvGrpSpPr/>
+        <p:nvPr/>
+      </p:nvGrpSpPr>
+      <p:grpSpPr/>
+      <p:sp>
+        <p:nvSpPr>
+          <p:cNvPr id="2" name="Rectangle 1"/>
+          <p:cNvSpPr/>
+          <p:nvPr/>
+        </p:nvSpPr>
+        <p:spPr>
+          <a:xfrm>
+            <a:off x="0" y="0"/>
+            <a:ext cx="12188952" cy="1280160"/>
+          </a:xfrm>
+          <a:prstGeom prst="rect">
+            <a:avLst/>
+          </a:prstGeom>
+          <a:solidFill>
+            <a:srgbClr val="1F3864"/>
+          </a:solidFill>
+          <a:ln>
+            <a:noFill/>
+          </a:ln>
+        </p:spPr>
+        <p:style>
+          <a:lnRef idx="1">
+            <a:schemeClr val="accent1"/>
+          </a:lnRef>
+          <a:fillRef idx="3">
+            <a:schemeClr val="accent1"/>
+          </a:fillRef>
+          <a:effectRef idx="2">
+            <a:schemeClr val="accent1"/>
+          </a:effectRef>
+          <a:fontRef idx="minor">
+            <a:schemeClr val="lt1"/>
+          </a:fontRef>
+        </p:style>
+        <p:txBody>
+          <a:bodyPr rtlCol="0" anchor="ctr"/>
+          <a:lstStyle/>
+          <a:p>
+            <a:pPr algn="ctr"/>
+          </a:p>
+        </p:txBody>
+      </p:sp>
+      <p:sp>
+        <p:nvSpPr>
+          <p:cNvPr id="3" name="TextBox 2"/>
           <p:cNvSpPr txBox="1"/>
           <p:nvPr/>
         </p:nvSpPr>
         <p:spPr>
           <a:xfrm>
-            <a:off x="365760" y="3008376"/>
-            <a:ext cx="11430000" cy="502920"/>
+            <a:off x="274320" y="91440"/>
+            <a:ext cx="11612880" cy="731520"/>
           </a:xfrm>
           <a:prstGeom prst="rect">
             <a:avLst/>
@@ -3497,11 +3670,2647 @@
           <a:p>
             <a:pPr algn="l"/>
             <a:r>
+              <a:rPr sz="3200" b="1">
+                <a:solidFill>
+                  <a:srgbClr val="FFFFFF"/>
+                </a:solidFill>
+              </a:rPr>
+              <a:t>Accuracy Summary &amp; Challenges</a:t>
+            </a:r>
+          </a:p>
+        </p:txBody>
+      </p:sp>
+      <p:sp>
+        <p:nvSpPr>
+          <p:cNvPr id="4" name="Rectangle 3"/>
+          <p:cNvSpPr/>
+          <p:nvPr/>
+        </p:nvSpPr>
+        <p:spPr>
+          <a:xfrm>
+            <a:off x="365760" y="1463040"/>
+            <a:ext cx="1005840" cy="329184"/>
+          </a:xfrm>
+          <a:prstGeom prst="rect">
+            <a:avLst/>
+          </a:prstGeom>
+          <a:solidFill>
+            <a:srgbClr val="1F3864"/>
+          </a:solidFill>
+          <a:ln>
+            <a:solidFill>
+              <a:srgbClr val="1F3864"/>
+            </a:solidFill>
+          </a:ln>
+        </p:spPr>
+        <p:style>
+          <a:lnRef idx="1">
+            <a:schemeClr val="accent1"/>
+          </a:lnRef>
+          <a:fillRef idx="3">
+            <a:schemeClr val="accent1"/>
+          </a:fillRef>
+          <a:effectRef idx="2">
+            <a:schemeClr val="accent1"/>
+          </a:effectRef>
+          <a:fontRef idx="minor">
+            <a:schemeClr val="lt1"/>
+          </a:fontRef>
+        </p:style>
+        <p:txBody>
+          <a:bodyPr rtlCol="0" anchor="ctr"/>
+          <a:lstStyle/>
+          <a:p>
+            <a:pPr algn="ctr"/>
+            <a:r>
+              <a:rPr sz="1300" b="1">
+                <a:solidFill>
+                  <a:srgbClr val="FFFFFF"/>
+                </a:solidFill>
+              </a:rPr>
+              <a:t>Image</a:t>
+            </a:r>
+          </a:p>
+        </p:txBody>
+      </p:sp>
+      <p:sp>
+        <p:nvSpPr>
+          <p:cNvPr id="5" name="Rectangle 4"/>
+          <p:cNvSpPr/>
+          <p:nvPr/>
+        </p:nvSpPr>
+        <p:spPr>
+          <a:xfrm>
+            <a:off x="1371600" y="1463040"/>
+            <a:ext cx="1005840" cy="329184"/>
+          </a:xfrm>
+          <a:prstGeom prst="rect">
+            <a:avLst/>
+          </a:prstGeom>
+          <a:solidFill>
+            <a:srgbClr val="1F3864"/>
+          </a:solidFill>
+          <a:ln>
+            <a:solidFill>
+              <a:srgbClr val="1F3864"/>
+            </a:solidFill>
+          </a:ln>
+        </p:spPr>
+        <p:style>
+          <a:lnRef idx="1">
+            <a:schemeClr val="accent1"/>
+          </a:lnRef>
+          <a:fillRef idx="3">
+            <a:schemeClr val="accent1"/>
+          </a:fillRef>
+          <a:effectRef idx="2">
+            <a:schemeClr val="accent1"/>
+          </a:effectRef>
+          <a:fontRef idx="minor">
+            <a:schemeClr val="lt1"/>
+          </a:fontRef>
+        </p:style>
+        <p:txBody>
+          <a:bodyPr rtlCol="0" anchor="ctr"/>
+          <a:lstStyle/>
+          <a:p>
+            <a:pPr algn="ctr"/>
+            <a:r>
+              <a:rPr sz="1300" b="1">
+                <a:solidFill>
+                  <a:srgbClr val="FFFFFF"/>
+                </a:solidFill>
+              </a:rPr>
+              <a:t>Lot</a:t>
+            </a:r>
+          </a:p>
+        </p:txBody>
+      </p:sp>
+      <p:sp>
+        <p:nvSpPr>
+          <p:cNvPr id="6" name="Rectangle 5"/>
+          <p:cNvSpPr/>
+          <p:nvPr/>
+        </p:nvSpPr>
+        <p:spPr>
+          <a:xfrm>
+            <a:off x="2377440" y="1463040"/>
+            <a:ext cx="1188720" cy="329184"/>
+          </a:xfrm>
+          <a:prstGeom prst="rect">
+            <a:avLst/>
+          </a:prstGeom>
+          <a:solidFill>
+            <a:srgbClr val="1F3864"/>
+          </a:solidFill>
+          <a:ln>
+            <a:solidFill>
+              <a:srgbClr val="1F3864"/>
+            </a:solidFill>
+          </a:ln>
+        </p:spPr>
+        <p:style>
+          <a:lnRef idx="1">
+            <a:schemeClr val="accent1"/>
+          </a:lnRef>
+          <a:fillRef idx="3">
+            <a:schemeClr val="accent1"/>
+          </a:fillRef>
+          <a:effectRef idx="2">
+            <a:schemeClr val="accent1"/>
+          </a:effectRef>
+          <a:fontRef idx="minor">
+            <a:schemeClr val="lt1"/>
+          </a:fontRef>
+        </p:style>
+        <p:txBody>
+          <a:bodyPr rtlCol="0" anchor="ctr"/>
+          <a:lstStyle/>
+          <a:p>
+            <a:pPr algn="ctr"/>
+            <a:r>
+              <a:rPr sz="1300" b="1">
+                <a:solidFill>
+                  <a:srgbClr val="FFFFFF"/>
+                </a:solidFill>
+              </a:rPr>
+              <a:t>Condition</a:t>
+            </a:r>
+          </a:p>
+        </p:txBody>
+      </p:sp>
+      <p:sp>
+        <p:nvSpPr>
+          <p:cNvPr id="7" name="Rectangle 6"/>
+          <p:cNvSpPr/>
+          <p:nvPr/>
+        </p:nvSpPr>
+        <p:spPr>
+          <a:xfrm>
+            <a:off x="3566160" y="1463040"/>
+            <a:ext cx="685800" cy="329184"/>
+          </a:xfrm>
+          <a:prstGeom prst="rect">
+            <a:avLst/>
+          </a:prstGeom>
+          <a:solidFill>
+            <a:srgbClr val="1F3864"/>
+          </a:solidFill>
+          <a:ln>
+            <a:solidFill>
+              <a:srgbClr val="1F3864"/>
+            </a:solidFill>
+          </a:ln>
+        </p:spPr>
+        <p:style>
+          <a:lnRef idx="1">
+            <a:schemeClr val="accent1"/>
+          </a:lnRef>
+          <a:fillRef idx="3">
+            <a:schemeClr val="accent1"/>
+          </a:fillRef>
+          <a:effectRef idx="2">
+            <a:schemeClr val="accent1"/>
+          </a:effectRef>
+          <a:fontRef idx="minor">
+            <a:schemeClr val="lt1"/>
+          </a:fontRef>
+        </p:style>
+        <p:txBody>
+          <a:bodyPr rtlCol="0" anchor="ctr"/>
+          <a:lstStyle/>
+          <a:p>
+            <a:pPr algn="ctr"/>
+            <a:r>
+              <a:rPr sz="1300" b="1">
+                <a:solidFill>
+                  <a:srgbClr val="FFFFFF"/>
+                </a:solidFill>
+              </a:rPr>
+              <a:t>Occ</a:t>
+            </a:r>
+          </a:p>
+        </p:txBody>
+      </p:sp>
+      <p:sp>
+        <p:nvSpPr>
+          <p:cNvPr id="8" name="Rectangle 7"/>
+          <p:cNvSpPr/>
+          <p:nvPr/>
+        </p:nvSpPr>
+        <p:spPr>
+          <a:xfrm>
+            <a:off x="4251960" y="1463040"/>
+            <a:ext cx="685800" cy="329184"/>
+          </a:xfrm>
+          <a:prstGeom prst="rect">
+            <a:avLst/>
+          </a:prstGeom>
+          <a:solidFill>
+            <a:srgbClr val="1F3864"/>
+          </a:solidFill>
+          <a:ln>
+            <a:solidFill>
+              <a:srgbClr val="1F3864"/>
+            </a:solidFill>
+          </a:ln>
+        </p:spPr>
+        <p:style>
+          <a:lnRef idx="1">
+            <a:schemeClr val="accent1"/>
+          </a:lnRef>
+          <a:fillRef idx="3">
+            <a:schemeClr val="accent1"/>
+          </a:fillRef>
+          <a:effectRef idx="2">
+            <a:schemeClr val="accent1"/>
+          </a:effectRef>
+          <a:fontRef idx="minor">
+            <a:schemeClr val="lt1"/>
+          </a:fontRef>
+        </p:style>
+        <p:txBody>
+          <a:bodyPr rtlCol="0" anchor="ctr"/>
+          <a:lstStyle/>
+          <a:p>
+            <a:pPr algn="ctr"/>
+            <a:r>
+              <a:rPr sz="1300" b="1">
+                <a:solidFill>
+                  <a:srgbClr val="FFFFFF"/>
+                </a:solidFill>
+              </a:rPr>
+              <a:t>Emp</a:t>
+            </a:r>
+          </a:p>
+        </p:txBody>
+      </p:sp>
+      <p:sp>
+        <p:nvSpPr>
+          <p:cNvPr id="9" name="Rectangle 8"/>
+          <p:cNvSpPr/>
+          <p:nvPr/>
+        </p:nvSpPr>
+        <p:spPr>
+          <a:xfrm>
+            <a:off x="4937760" y="1463040"/>
+            <a:ext cx="777240" cy="329184"/>
+          </a:xfrm>
+          <a:prstGeom prst="rect">
+            <a:avLst/>
+          </a:prstGeom>
+          <a:solidFill>
+            <a:srgbClr val="1F3864"/>
+          </a:solidFill>
+          <a:ln>
+            <a:solidFill>
+              <a:srgbClr val="1F3864"/>
+            </a:solidFill>
+          </a:ln>
+        </p:spPr>
+        <p:style>
+          <a:lnRef idx="1">
+            <a:schemeClr val="accent1"/>
+          </a:lnRef>
+          <a:fillRef idx="3">
+            <a:schemeClr val="accent1"/>
+          </a:fillRef>
+          <a:effectRef idx="2">
+            <a:schemeClr val="accent1"/>
+          </a:effectRef>
+          <a:fontRef idx="minor">
+            <a:schemeClr val="lt1"/>
+          </a:fontRef>
+        </p:style>
+        <p:txBody>
+          <a:bodyPr rtlCol="0" anchor="ctr"/>
+          <a:lstStyle/>
+          <a:p>
+            <a:pPr algn="ctr"/>
+            <a:r>
+              <a:rPr sz="1300" b="1">
+                <a:solidFill>
+                  <a:srgbClr val="FFFFFF"/>
+                </a:solidFill>
+              </a:rPr>
+              <a:t>Total</a:t>
+            </a:r>
+          </a:p>
+        </p:txBody>
+      </p:sp>
+      <p:sp>
+        <p:nvSpPr>
+          <p:cNvPr id="10" name="Rectangle 9"/>
+          <p:cNvSpPr/>
+          <p:nvPr/>
+        </p:nvSpPr>
+        <p:spPr>
+          <a:xfrm>
+            <a:off x="365760" y="1792224"/>
+            <a:ext cx="1005840" cy="329184"/>
+          </a:xfrm>
+          <a:prstGeom prst="rect">
+            <a:avLst/>
+          </a:prstGeom>
+          <a:solidFill>
+            <a:srgbClr val="FFFFFF"/>
+          </a:solidFill>
+          <a:ln>
+            <a:solidFill>
+              <a:srgbClr val="1F3864"/>
+            </a:solidFill>
+          </a:ln>
+        </p:spPr>
+        <p:style>
+          <a:lnRef idx="1">
+            <a:schemeClr val="accent1"/>
+          </a:lnRef>
+          <a:fillRef idx="3">
+            <a:schemeClr val="accent1"/>
+          </a:fillRef>
+          <a:effectRef idx="2">
+            <a:schemeClr val="accent1"/>
+          </a:effectRef>
+          <a:fontRef idx="minor">
+            <a:schemeClr val="lt1"/>
+          </a:fontRef>
+        </p:style>
+        <p:txBody>
+          <a:bodyPr rtlCol="0" anchor="ctr"/>
+          <a:lstStyle/>
+          <a:p>
+            <a:pPr algn="ctr"/>
+            <a:r>
+              <a:rPr sz="1300" b="0">
+                <a:solidFill>
+                  <a:srgbClr val="444444"/>
+                </a:solidFill>
+              </a:rPr>
+              <a:t>PUCPR3</a:t>
+            </a:r>
+          </a:p>
+        </p:txBody>
+      </p:sp>
+      <p:sp>
+        <p:nvSpPr>
+          <p:cNvPr id="11" name="Rectangle 10"/>
+          <p:cNvSpPr/>
+          <p:nvPr/>
+        </p:nvSpPr>
+        <p:spPr>
+          <a:xfrm>
+            <a:off x="1371600" y="1792224"/>
+            <a:ext cx="1005840" cy="329184"/>
+          </a:xfrm>
+          <a:prstGeom prst="rect">
+            <a:avLst/>
+          </a:prstGeom>
+          <a:solidFill>
+            <a:srgbClr val="FFFFFF"/>
+          </a:solidFill>
+          <a:ln>
+            <a:solidFill>
+              <a:srgbClr val="1F3864"/>
+            </a:solidFill>
+          </a:ln>
+        </p:spPr>
+        <p:style>
+          <a:lnRef idx="1">
+            <a:schemeClr val="accent1"/>
+          </a:lnRef>
+          <a:fillRef idx="3">
+            <a:schemeClr val="accent1"/>
+          </a:fillRef>
+          <a:effectRef idx="2">
+            <a:schemeClr val="accent1"/>
+          </a:effectRef>
+          <a:fontRef idx="minor">
+            <a:schemeClr val="lt1"/>
+          </a:fontRef>
+        </p:style>
+        <p:txBody>
+          <a:bodyPr rtlCol="0" anchor="ctr"/>
+          <a:lstStyle/>
+          <a:p>
+            <a:pPr algn="ctr"/>
+            <a:r>
+              <a:rPr sz="1300" b="0">
+                <a:solidFill>
+                  <a:srgbClr val="444444"/>
+                </a:solidFill>
+              </a:rPr>
+              <a:t>PUCPR</a:t>
+            </a:r>
+          </a:p>
+        </p:txBody>
+      </p:sp>
+      <p:sp>
+        <p:nvSpPr>
+          <p:cNvPr id="12" name="Rectangle 11"/>
+          <p:cNvSpPr/>
+          <p:nvPr/>
+        </p:nvSpPr>
+        <p:spPr>
+          <a:xfrm>
+            <a:off x="2377440" y="1792224"/>
+            <a:ext cx="1188720" cy="329184"/>
+          </a:xfrm>
+          <a:prstGeom prst="rect">
+            <a:avLst/>
+          </a:prstGeom>
+          <a:solidFill>
+            <a:srgbClr val="FFFFFF"/>
+          </a:solidFill>
+          <a:ln>
+            <a:solidFill>
+              <a:srgbClr val="1F3864"/>
+            </a:solidFill>
+          </a:ln>
+        </p:spPr>
+        <p:style>
+          <a:lnRef idx="1">
+            <a:schemeClr val="accent1"/>
+          </a:lnRef>
+          <a:fillRef idx="3">
+            <a:schemeClr val="accent1"/>
+          </a:fillRef>
+          <a:effectRef idx="2">
+            <a:schemeClr val="accent1"/>
+          </a:effectRef>
+          <a:fontRef idx="minor">
+            <a:schemeClr val="lt1"/>
+          </a:fontRef>
+        </p:style>
+        <p:txBody>
+          <a:bodyPr rtlCol="0" anchor="ctr"/>
+          <a:lstStyle/>
+          <a:p>
+            <a:pPr algn="ctr"/>
+            <a:r>
+              <a:rPr sz="1300" b="0">
+                <a:solidFill>
+                  <a:srgbClr val="444444"/>
+                </a:solidFill>
+              </a:rPr>
+              <a:t>Empty ref</a:t>
+            </a:r>
+          </a:p>
+        </p:txBody>
+      </p:sp>
+      <p:sp>
+        <p:nvSpPr>
+          <p:cNvPr id="13" name="Rectangle 12"/>
+          <p:cNvSpPr/>
+          <p:nvPr/>
+        </p:nvSpPr>
+        <p:spPr>
+          <a:xfrm>
+            <a:off x="3566160" y="1792224"/>
+            <a:ext cx="685800" cy="329184"/>
+          </a:xfrm>
+          <a:prstGeom prst="rect">
+            <a:avLst/>
+          </a:prstGeom>
+          <a:solidFill>
+            <a:srgbClr val="FFFFFF"/>
+          </a:solidFill>
+          <a:ln>
+            <a:solidFill>
+              <a:srgbClr val="1F3864"/>
+            </a:solidFill>
+          </a:ln>
+        </p:spPr>
+        <p:style>
+          <a:lnRef idx="1">
+            <a:schemeClr val="accent1"/>
+          </a:lnRef>
+          <a:fillRef idx="3">
+            <a:schemeClr val="accent1"/>
+          </a:fillRef>
+          <a:effectRef idx="2">
+            <a:schemeClr val="accent1"/>
+          </a:effectRef>
+          <a:fontRef idx="minor">
+            <a:schemeClr val="lt1"/>
+          </a:fontRef>
+        </p:style>
+        <p:txBody>
+          <a:bodyPr rtlCol="0" anchor="ctr"/>
+          <a:lstStyle/>
+          <a:p>
+            <a:pPr algn="ctr"/>
+            <a:r>
+              <a:rPr sz="1300" b="0">
+                <a:solidFill>
+                  <a:srgbClr val="444444"/>
+                </a:solidFill>
+              </a:rPr>
+              <a:t>0</a:t>
+            </a:r>
+          </a:p>
+        </p:txBody>
+      </p:sp>
+      <p:sp>
+        <p:nvSpPr>
+          <p:cNvPr id="14" name="Rectangle 13"/>
+          <p:cNvSpPr/>
+          <p:nvPr/>
+        </p:nvSpPr>
+        <p:spPr>
+          <a:xfrm>
+            <a:off x="4251960" y="1792224"/>
+            <a:ext cx="685800" cy="329184"/>
+          </a:xfrm>
+          <a:prstGeom prst="rect">
+            <a:avLst/>
+          </a:prstGeom>
+          <a:solidFill>
+            <a:srgbClr val="FFFFFF"/>
+          </a:solidFill>
+          <a:ln>
+            <a:solidFill>
+              <a:srgbClr val="1F3864"/>
+            </a:solidFill>
+          </a:ln>
+        </p:spPr>
+        <p:style>
+          <a:lnRef idx="1">
+            <a:schemeClr val="accent1"/>
+          </a:lnRef>
+          <a:fillRef idx="3">
+            <a:schemeClr val="accent1"/>
+          </a:fillRef>
+          <a:effectRef idx="2">
+            <a:schemeClr val="accent1"/>
+          </a:effectRef>
+          <a:fontRef idx="minor">
+            <a:schemeClr val="lt1"/>
+          </a:fontRef>
+        </p:style>
+        <p:txBody>
+          <a:bodyPr rtlCol="0" anchor="ctr"/>
+          <a:lstStyle/>
+          <a:p>
+            <a:pPr algn="ctr"/>
+            <a:r>
+              <a:rPr sz="1300" b="0">
+                <a:solidFill>
+                  <a:srgbClr val="444444"/>
+                </a:solidFill>
+              </a:rPr>
+              <a:t>43</a:t>
+            </a:r>
+          </a:p>
+        </p:txBody>
+      </p:sp>
+      <p:sp>
+        <p:nvSpPr>
+          <p:cNvPr id="15" name="Rectangle 14"/>
+          <p:cNvSpPr/>
+          <p:nvPr/>
+        </p:nvSpPr>
+        <p:spPr>
+          <a:xfrm>
+            <a:off x="4937760" y="1792224"/>
+            <a:ext cx="777240" cy="329184"/>
+          </a:xfrm>
+          <a:prstGeom prst="rect">
+            <a:avLst/>
+          </a:prstGeom>
+          <a:solidFill>
+            <a:srgbClr val="FFFFFF"/>
+          </a:solidFill>
+          <a:ln>
+            <a:solidFill>
+              <a:srgbClr val="1F3864"/>
+            </a:solidFill>
+          </a:ln>
+        </p:spPr>
+        <p:style>
+          <a:lnRef idx="1">
+            <a:schemeClr val="accent1"/>
+          </a:lnRef>
+          <a:fillRef idx="3">
+            <a:schemeClr val="accent1"/>
+          </a:fillRef>
+          <a:effectRef idx="2">
+            <a:schemeClr val="accent1"/>
+          </a:effectRef>
+          <a:fontRef idx="minor">
+            <a:schemeClr val="lt1"/>
+          </a:fontRef>
+        </p:style>
+        <p:txBody>
+          <a:bodyPr rtlCol="0" anchor="ctr"/>
+          <a:lstStyle/>
+          <a:p>
+            <a:pPr algn="ctr"/>
+            <a:r>
+              <a:rPr sz="1300" b="0">
+                <a:solidFill>
+                  <a:srgbClr val="444444"/>
+                </a:solidFill>
+              </a:rPr>
+              <a:t>43</a:t>
+            </a:r>
+          </a:p>
+        </p:txBody>
+      </p:sp>
+      <p:sp>
+        <p:nvSpPr>
+          <p:cNvPr id="16" name="Rectangle 15"/>
+          <p:cNvSpPr/>
+          <p:nvPr/>
+        </p:nvSpPr>
+        <p:spPr>
+          <a:xfrm>
+            <a:off x="365760" y="2121408"/>
+            <a:ext cx="1005840" cy="329184"/>
+          </a:xfrm>
+          <a:prstGeom prst="rect">
+            <a:avLst/>
+          </a:prstGeom>
+          <a:solidFill>
+            <a:srgbClr val="E8F0F8"/>
+          </a:solidFill>
+          <a:ln>
+            <a:solidFill>
+              <a:srgbClr val="1F3864"/>
+            </a:solidFill>
+          </a:ln>
+        </p:spPr>
+        <p:style>
+          <a:lnRef idx="1">
+            <a:schemeClr val="accent1"/>
+          </a:lnRef>
+          <a:fillRef idx="3">
+            <a:schemeClr val="accent1"/>
+          </a:fillRef>
+          <a:effectRef idx="2">
+            <a:schemeClr val="accent1"/>
+          </a:effectRef>
+          <a:fontRef idx="minor">
+            <a:schemeClr val="lt1"/>
+          </a:fontRef>
+        </p:style>
+        <p:txBody>
+          <a:bodyPr rtlCol="0" anchor="ctr"/>
+          <a:lstStyle/>
+          <a:p>
+            <a:pPr algn="ctr"/>
+            <a:r>
+              <a:rPr sz="1300" b="0">
+                <a:solidFill>
+                  <a:srgbClr val="444444"/>
+                </a:solidFill>
+              </a:rPr>
+              <a:t>PUCPR1</a:t>
+            </a:r>
+          </a:p>
+        </p:txBody>
+      </p:sp>
+      <p:sp>
+        <p:nvSpPr>
+          <p:cNvPr id="17" name="Rectangle 16"/>
+          <p:cNvSpPr/>
+          <p:nvPr/>
+        </p:nvSpPr>
+        <p:spPr>
+          <a:xfrm>
+            <a:off x="1371600" y="2121408"/>
+            <a:ext cx="1005840" cy="329184"/>
+          </a:xfrm>
+          <a:prstGeom prst="rect">
+            <a:avLst/>
+          </a:prstGeom>
+          <a:solidFill>
+            <a:srgbClr val="E8F0F8"/>
+          </a:solidFill>
+          <a:ln>
+            <a:solidFill>
+              <a:srgbClr val="1F3864"/>
+            </a:solidFill>
+          </a:ln>
+        </p:spPr>
+        <p:style>
+          <a:lnRef idx="1">
+            <a:schemeClr val="accent1"/>
+          </a:lnRef>
+          <a:fillRef idx="3">
+            <a:schemeClr val="accent1"/>
+          </a:fillRef>
+          <a:effectRef idx="2">
+            <a:schemeClr val="accent1"/>
+          </a:effectRef>
+          <a:fontRef idx="minor">
+            <a:schemeClr val="lt1"/>
+          </a:fontRef>
+        </p:style>
+        <p:txBody>
+          <a:bodyPr rtlCol="0" anchor="ctr"/>
+          <a:lstStyle/>
+          <a:p>
+            <a:pPr algn="ctr"/>
+            <a:r>
+              <a:rPr sz="1300" b="0">
+                <a:solidFill>
+                  <a:srgbClr val="444444"/>
+                </a:solidFill>
+              </a:rPr>
+              <a:t>PUCPR</a:t>
+            </a:r>
+          </a:p>
+        </p:txBody>
+      </p:sp>
+      <p:sp>
+        <p:nvSpPr>
+          <p:cNvPr id="18" name="Rectangle 17"/>
+          <p:cNvSpPr/>
+          <p:nvPr/>
+        </p:nvSpPr>
+        <p:spPr>
+          <a:xfrm>
+            <a:off x="2377440" y="2121408"/>
+            <a:ext cx="1188720" cy="329184"/>
+          </a:xfrm>
+          <a:prstGeom prst="rect">
+            <a:avLst/>
+          </a:prstGeom>
+          <a:solidFill>
+            <a:srgbClr val="E8F0F8"/>
+          </a:solidFill>
+          <a:ln>
+            <a:solidFill>
+              <a:srgbClr val="1F3864"/>
+            </a:solidFill>
+          </a:ln>
+        </p:spPr>
+        <p:style>
+          <a:lnRef idx="1">
+            <a:schemeClr val="accent1"/>
+          </a:lnRef>
+          <a:fillRef idx="3">
+            <a:schemeClr val="accent1"/>
+          </a:fillRef>
+          <a:effectRef idx="2">
+            <a:schemeClr val="accent1"/>
+          </a:effectRef>
+          <a:fontRef idx="minor">
+            <a:schemeClr val="lt1"/>
+          </a:fontRef>
+        </p:style>
+        <p:txBody>
+          <a:bodyPr rtlCol="0" anchor="ctr"/>
+          <a:lstStyle/>
+          <a:p>
+            <a:pPr algn="ctr"/>
+            <a:r>
+              <a:rPr sz="1300" b="0">
+                <a:solidFill>
+                  <a:srgbClr val="444444"/>
+                </a:solidFill>
+              </a:rPr>
+              <a:t>Partial</a:t>
+            </a:r>
+          </a:p>
+        </p:txBody>
+      </p:sp>
+      <p:sp>
+        <p:nvSpPr>
+          <p:cNvPr id="19" name="Rectangle 18"/>
+          <p:cNvSpPr/>
+          <p:nvPr/>
+        </p:nvSpPr>
+        <p:spPr>
+          <a:xfrm>
+            <a:off x="3566160" y="2121408"/>
+            <a:ext cx="685800" cy="329184"/>
+          </a:xfrm>
+          <a:prstGeom prst="rect">
+            <a:avLst/>
+          </a:prstGeom>
+          <a:solidFill>
+            <a:srgbClr val="E8F0F8"/>
+          </a:solidFill>
+          <a:ln>
+            <a:solidFill>
+              <a:srgbClr val="1F3864"/>
+            </a:solidFill>
+          </a:ln>
+        </p:spPr>
+        <p:style>
+          <a:lnRef idx="1">
+            <a:schemeClr val="accent1"/>
+          </a:lnRef>
+          <a:fillRef idx="3">
+            <a:schemeClr val="accent1"/>
+          </a:fillRef>
+          <a:effectRef idx="2">
+            <a:schemeClr val="accent1"/>
+          </a:effectRef>
+          <a:fontRef idx="minor">
+            <a:schemeClr val="lt1"/>
+          </a:fontRef>
+        </p:style>
+        <p:txBody>
+          <a:bodyPr rtlCol="0" anchor="ctr"/>
+          <a:lstStyle/>
+          <a:p>
+            <a:pPr algn="ctr"/>
+            <a:r>
+              <a:rPr sz="1300" b="0">
+                <a:solidFill>
+                  <a:srgbClr val="444444"/>
+                </a:solidFill>
+              </a:rPr>
+              <a:t>26</a:t>
+            </a:r>
+          </a:p>
+        </p:txBody>
+      </p:sp>
+      <p:sp>
+        <p:nvSpPr>
+          <p:cNvPr id="20" name="Rectangle 19"/>
+          <p:cNvSpPr/>
+          <p:nvPr/>
+        </p:nvSpPr>
+        <p:spPr>
+          <a:xfrm>
+            <a:off x="4251960" y="2121408"/>
+            <a:ext cx="685800" cy="329184"/>
+          </a:xfrm>
+          <a:prstGeom prst="rect">
+            <a:avLst/>
+          </a:prstGeom>
+          <a:solidFill>
+            <a:srgbClr val="E8F0F8"/>
+          </a:solidFill>
+          <a:ln>
+            <a:solidFill>
+              <a:srgbClr val="1F3864"/>
+            </a:solidFill>
+          </a:ln>
+        </p:spPr>
+        <p:style>
+          <a:lnRef idx="1">
+            <a:schemeClr val="accent1"/>
+          </a:lnRef>
+          <a:fillRef idx="3">
+            <a:schemeClr val="accent1"/>
+          </a:fillRef>
+          <a:effectRef idx="2">
+            <a:schemeClr val="accent1"/>
+          </a:effectRef>
+          <a:fontRef idx="minor">
+            <a:schemeClr val="lt1"/>
+          </a:fontRef>
+        </p:style>
+        <p:txBody>
+          <a:bodyPr rtlCol="0" anchor="ctr"/>
+          <a:lstStyle/>
+          <a:p>
+            <a:pPr algn="ctr"/>
+            <a:r>
+              <a:rPr sz="1300" b="0">
+                <a:solidFill>
+                  <a:srgbClr val="444444"/>
+                </a:solidFill>
+              </a:rPr>
+              <a:t>17</a:t>
+            </a:r>
+          </a:p>
+        </p:txBody>
+      </p:sp>
+      <p:sp>
+        <p:nvSpPr>
+          <p:cNvPr id="21" name="Rectangle 20"/>
+          <p:cNvSpPr/>
+          <p:nvPr/>
+        </p:nvSpPr>
+        <p:spPr>
+          <a:xfrm>
+            <a:off x="4937760" y="2121408"/>
+            <a:ext cx="777240" cy="329184"/>
+          </a:xfrm>
+          <a:prstGeom prst="rect">
+            <a:avLst/>
+          </a:prstGeom>
+          <a:solidFill>
+            <a:srgbClr val="E8F0F8"/>
+          </a:solidFill>
+          <a:ln>
+            <a:solidFill>
+              <a:srgbClr val="1F3864"/>
+            </a:solidFill>
+          </a:ln>
+        </p:spPr>
+        <p:style>
+          <a:lnRef idx="1">
+            <a:schemeClr val="accent1"/>
+          </a:lnRef>
+          <a:fillRef idx="3">
+            <a:schemeClr val="accent1"/>
+          </a:fillRef>
+          <a:effectRef idx="2">
+            <a:schemeClr val="accent1"/>
+          </a:effectRef>
+          <a:fontRef idx="minor">
+            <a:schemeClr val="lt1"/>
+          </a:fontRef>
+        </p:style>
+        <p:txBody>
+          <a:bodyPr rtlCol="0" anchor="ctr"/>
+          <a:lstStyle/>
+          <a:p>
+            <a:pPr algn="ctr"/>
+            <a:r>
+              <a:rPr sz="1300" b="0">
+                <a:solidFill>
+                  <a:srgbClr val="444444"/>
+                </a:solidFill>
+              </a:rPr>
+              <a:t>43</a:t>
+            </a:r>
+          </a:p>
+        </p:txBody>
+      </p:sp>
+      <p:sp>
+        <p:nvSpPr>
+          <p:cNvPr id="22" name="Rectangle 21"/>
+          <p:cNvSpPr/>
+          <p:nvPr/>
+        </p:nvSpPr>
+        <p:spPr>
+          <a:xfrm>
+            <a:off x="365760" y="2450592"/>
+            <a:ext cx="1005840" cy="329184"/>
+          </a:xfrm>
+          <a:prstGeom prst="rect">
+            <a:avLst/>
+          </a:prstGeom>
+          <a:solidFill>
+            <a:srgbClr val="FFFFFF"/>
+          </a:solidFill>
+          <a:ln>
+            <a:solidFill>
+              <a:srgbClr val="1F3864"/>
+            </a:solidFill>
+          </a:ln>
+        </p:spPr>
+        <p:style>
+          <a:lnRef idx="1">
+            <a:schemeClr val="accent1"/>
+          </a:lnRef>
+          <a:fillRef idx="3">
+            <a:schemeClr val="accent1"/>
+          </a:fillRef>
+          <a:effectRef idx="2">
+            <a:schemeClr val="accent1"/>
+          </a:effectRef>
+          <a:fontRef idx="minor">
+            <a:schemeClr val="lt1"/>
+          </a:fontRef>
+        </p:style>
+        <p:txBody>
+          <a:bodyPr rtlCol="0" anchor="ctr"/>
+          <a:lstStyle/>
+          <a:p>
+            <a:pPr algn="ctr"/>
+            <a:r>
+              <a:rPr sz="1300" b="0">
+                <a:solidFill>
+                  <a:srgbClr val="444444"/>
+                </a:solidFill>
+              </a:rPr>
+              <a:t>PUCPR2</a:t>
+            </a:r>
+          </a:p>
+        </p:txBody>
+      </p:sp>
+      <p:sp>
+        <p:nvSpPr>
+          <p:cNvPr id="23" name="Rectangle 22"/>
+          <p:cNvSpPr/>
+          <p:nvPr/>
+        </p:nvSpPr>
+        <p:spPr>
+          <a:xfrm>
+            <a:off x="1371600" y="2450592"/>
+            <a:ext cx="1005840" cy="329184"/>
+          </a:xfrm>
+          <a:prstGeom prst="rect">
+            <a:avLst/>
+          </a:prstGeom>
+          <a:solidFill>
+            <a:srgbClr val="FFFFFF"/>
+          </a:solidFill>
+          <a:ln>
+            <a:solidFill>
+              <a:srgbClr val="1F3864"/>
+            </a:solidFill>
+          </a:ln>
+        </p:spPr>
+        <p:style>
+          <a:lnRef idx="1">
+            <a:schemeClr val="accent1"/>
+          </a:lnRef>
+          <a:fillRef idx="3">
+            <a:schemeClr val="accent1"/>
+          </a:fillRef>
+          <a:effectRef idx="2">
+            <a:schemeClr val="accent1"/>
+          </a:effectRef>
+          <a:fontRef idx="minor">
+            <a:schemeClr val="lt1"/>
+          </a:fontRef>
+        </p:style>
+        <p:txBody>
+          <a:bodyPr rtlCol="0" anchor="ctr"/>
+          <a:lstStyle/>
+          <a:p>
+            <a:pPr algn="ctr"/>
+            <a:r>
+              <a:rPr sz="1300" b="0">
+                <a:solidFill>
+                  <a:srgbClr val="444444"/>
+                </a:solidFill>
+              </a:rPr>
+              <a:t>PUCPR</a:t>
+            </a:r>
+          </a:p>
+        </p:txBody>
+      </p:sp>
+      <p:sp>
+        <p:nvSpPr>
+          <p:cNvPr id="24" name="Rectangle 23"/>
+          <p:cNvSpPr/>
+          <p:nvPr/>
+        </p:nvSpPr>
+        <p:spPr>
+          <a:xfrm>
+            <a:off x="2377440" y="2450592"/>
+            <a:ext cx="1188720" cy="329184"/>
+          </a:xfrm>
+          <a:prstGeom prst="rect">
+            <a:avLst/>
+          </a:prstGeom>
+          <a:solidFill>
+            <a:srgbClr val="FFFFFF"/>
+          </a:solidFill>
+          <a:ln>
+            <a:solidFill>
+              <a:srgbClr val="1F3864"/>
+            </a:solidFill>
+          </a:ln>
+        </p:spPr>
+        <p:style>
+          <a:lnRef idx="1">
+            <a:schemeClr val="accent1"/>
+          </a:lnRef>
+          <a:fillRef idx="3">
+            <a:schemeClr val="accent1"/>
+          </a:fillRef>
+          <a:effectRef idx="2">
+            <a:schemeClr val="accent1"/>
+          </a:effectRef>
+          <a:fontRef idx="minor">
+            <a:schemeClr val="lt1"/>
+          </a:fontRef>
+        </p:style>
+        <p:txBody>
+          <a:bodyPr rtlCol="0" anchor="ctr"/>
+          <a:lstStyle/>
+          <a:p>
+            <a:pPr algn="ctr"/>
+            <a:r>
+              <a:rPr sz="1300" b="0">
+                <a:solidFill>
+                  <a:srgbClr val="444444"/>
+                </a:solidFill>
+              </a:rPr>
+              <a:t>Heavy</a:t>
+            </a:r>
+          </a:p>
+        </p:txBody>
+      </p:sp>
+      <p:sp>
+        <p:nvSpPr>
+          <p:cNvPr id="25" name="Rectangle 24"/>
+          <p:cNvSpPr/>
+          <p:nvPr/>
+        </p:nvSpPr>
+        <p:spPr>
+          <a:xfrm>
+            <a:off x="3566160" y="2450592"/>
+            <a:ext cx="685800" cy="329184"/>
+          </a:xfrm>
+          <a:prstGeom prst="rect">
+            <a:avLst/>
+          </a:prstGeom>
+          <a:solidFill>
+            <a:srgbClr val="FFFFFF"/>
+          </a:solidFill>
+          <a:ln>
+            <a:solidFill>
+              <a:srgbClr val="1F3864"/>
+            </a:solidFill>
+          </a:ln>
+        </p:spPr>
+        <p:style>
+          <a:lnRef idx="1">
+            <a:schemeClr val="accent1"/>
+          </a:lnRef>
+          <a:fillRef idx="3">
+            <a:schemeClr val="accent1"/>
+          </a:fillRef>
+          <a:effectRef idx="2">
+            <a:schemeClr val="accent1"/>
+          </a:effectRef>
+          <a:fontRef idx="minor">
+            <a:schemeClr val="lt1"/>
+          </a:fontRef>
+        </p:style>
+        <p:txBody>
+          <a:bodyPr rtlCol="0" anchor="ctr"/>
+          <a:lstStyle/>
+          <a:p>
+            <a:pPr algn="ctr"/>
+            <a:r>
+              <a:rPr sz="1300" b="0">
+                <a:solidFill>
+                  <a:srgbClr val="444444"/>
+                </a:solidFill>
+              </a:rPr>
+              <a:t>32</a:t>
+            </a:r>
+          </a:p>
+        </p:txBody>
+      </p:sp>
+      <p:sp>
+        <p:nvSpPr>
+          <p:cNvPr id="26" name="Rectangle 25"/>
+          <p:cNvSpPr/>
+          <p:nvPr/>
+        </p:nvSpPr>
+        <p:spPr>
+          <a:xfrm>
+            <a:off x="4251960" y="2450592"/>
+            <a:ext cx="685800" cy="329184"/>
+          </a:xfrm>
+          <a:prstGeom prst="rect">
+            <a:avLst/>
+          </a:prstGeom>
+          <a:solidFill>
+            <a:srgbClr val="FFFFFF"/>
+          </a:solidFill>
+          <a:ln>
+            <a:solidFill>
+              <a:srgbClr val="1F3864"/>
+            </a:solidFill>
+          </a:ln>
+        </p:spPr>
+        <p:style>
+          <a:lnRef idx="1">
+            <a:schemeClr val="accent1"/>
+          </a:lnRef>
+          <a:fillRef idx="3">
+            <a:schemeClr val="accent1"/>
+          </a:fillRef>
+          <a:effectRef idx="2">
+            <a:schemeClr val="accent1"/>
+          </a:effectRef>
+          <a:fontRef idx="minor">
+            <a:schemeClr val="lt1"/>
+          </a:fontRef>
+        </p:style>
+        <p:txBody>
+          <a:bodyPr rtlCol="0" anchor="ctr"/>
+          <a:lstStyle/>
+          <a:p>
+            <a:pPr algn="ctr"/>
+            <a:r>
+              <a:rPr sz="1300" b="0">
+                <a:solidFill>
+                  <a:srgbClr val="444444"/>
+                </a:solidFill>
+              </a:rPr>
+              <a:t>11</a:t>
+            </a:r>
+          </a:p>
+        </p:txBody>
+      </p:sp>
+      <p:sp>
+        <p:nvSpPr>
+          <p:cNvPr id="27" name="Rectangle 26"/>
+          <p:cNvSpPr/>
+          <p:nvPr/>
+        </p:nvSpPr>
+        <p:spPr>
+          <a:xfrm>
+            <a:off x="4937760" y="2450592"/>
+            <a:ext cx="777240" cy="329184"/>
+          </a:xfrm>
+          <a:prstGeom prst="rect">
+            <a:avLst/>
+          </a:prstGeom>
+          <a:solidFill>
+            <a:srgbClr val="FFFFFF"/>
+          </a:solidFill>
+          <a:ln>
+            <a:solidFill>
+              <a:srgbClr val="1F3864"/>
+            </a:solidFill>
+          </a:ln>
+        </p:spPr>
+        <p:style>
+          <a:lnRef idx="1">
+            <a:schemeClr val="accent1"/>
+          </a:lnRef>
+          <a:fillRef idx="3">
+            <a:schemeClr val="accent1"/>
+          </a:fillRef>
+          <a:effectRef idx="2">
+            <a:schemeClr val="accent1"/>
+          </a:effectRef>
+          <a:fontRef idx="minor">
+            <a:schemeClr val="lt1"/>
+          </a:fontRef>
+        </p:style>
+        <p:txBody>
+          <a:bodyPr rtlCol="0" anchor="ctr"/>
+          <a:lstStyle/>
+          <a:p>
+            <a:pPr algn="ctr"/>
+            <a:r>
+              <a:rPr sz="1300" b="0">
+                <a:solidFill>
+                  <a:srgbClr val="444444"/>
+                </a:solidFill>
+              </a:rPr>
+              <a:t>43</a:t>
+            </a:r>
+          </a:p>
+        </p:txBody>
+      </p:sp>
+      <p:sp>
+        <p:nvSpPr>
+          <p:cNvPr id="28" name="Rectangle 27"/>
+          <p:cNvSpPr/>
+          <p:nvPr/>
+        </p:nvSpPr>
+        <p:spPr>
+          <a:xfrm>
+            <a:off x="365760" y="2779776"/>
+            <a:ext cx="1005840" cy="329184"/>
+          </a:xfrm>
+          <a:prstGeom prst="rect">
+            <a:avLst/>
+          </a:prstGeom>
+          <a:solidFill>
+            <a:srgbClr val="E8F0F8"/>
+          </a:solidFill>
+          <a:ln>
+            <a:solidFill>
+              <a:srgbClr val="1F3864"/>
+            </a:solidFill>
+          </a:ln>
+        </p:spPr>
+        <p:style>
+          <a:lnRef idx="1">
+            <a:schemeClr val="accent1"/>
+          </a:lnRef>
+          <a:fillRef idx="3">
+            <a:schemeClr val="accent1"/>
+          </a:fillRef>
+          <a:effectRef idx="2">
+            <a:schemeClr val="accent1"/>
+          </a:effectRef>
+          <a:fontRef idx="minor">
+            <a:schemeClr val="lt1"/>
+          </a:fontRef>
+        </p:style>
+        <p:txBody>
+          <a:bodyPr rtlCol="0" anchor="ctr"/>
+          <a:lstStyle/>
+          <a:p>
+            <a:pPr algn="ctr"/>
+            <a:r>
+              <a:rPr sz="1300" b="0">
+                <a:solidFill>
+                  <a:srgbClr val="444444"/>
+                </a:solidFill>
+              </a:rPr>
+              <a:t>UFPR1</a:t>
+            </a:r>
+          </a:p>
+        </p:txBody>
+      </p:sp>
+      <p:sp>
+        <p:nvSpPr>
+          <p:cNvPr id="29" name="Rectangle 28"/>
+          <p:cNvSpPr/>
+          <p:nvPr/>
+        </p:nvSpPr>
+        <p:spPr>
+          <a:xfrm>
+            <a:off x="1371600" y="2779776"/>
+            <a:ext cx="1005840" cy="329184"/>
+          </a:xfrm>
+          <a:prstGeom prst="rect">
+            <a:avLst/>
+          </a:prstGeom>
+          <a:solidFill>
+            <a:srgbClr val="E8F0F8"/>
+          </a:solidFill>
+          <a:ln>
+            <a:solidFill>
+              <a:srgbClr val="1F3864"/>
+            </a:solidFill>
+          </a:ln>
+        </p:spPr>
+        <p:style>
+          <a:lnRef idx="1">
+            <a:schemeClr val="accent1"/>
+          </a:lnRef>
+          <a:fillRef idx="3">
+            <a:schemeClr val="accent1"/>
+          </a:fillRef>
+          <a:effectRef idx="2">
+            <a:schemeClr val="accent1"/>
+          </a:effectRef>
+          <a:fontRef idx="minor">
+            <a:schemeClr val="lt1"/>
+          </a:fontRef>
+        </p:style>
+        <p:txBody>
+          <a:bodyPr rtlCol="0" anchor="ctr"/>
+          <a:lstStyle/>
+          <a:p>
+            <a:pPr algn="ctr"/>
+            <a:r>
+              <a:rPr sz="1300" b="0">
+                <a:solidFill>
+                  <a:srgbClr val="444444"/>
+                </a:solidFill>
+              </a:rPr>
+              <a:t>UFPR04</a:t>
+            </a:r>
+          </a:p>
+        </p:txBody>
+      </p:sp>
+      <p:sp>
+        <p:nvSpPr>
+          <p:cNvPr id="30" name="Rectangle 29"/>
+          <p:cNvSpPr/>
+          <p:nvPr/>
+        </p:nvSpPr>
+        <p:spPr>
+          <a:xfrm>
+            <a:off x="2377440" y="2779776"/>
+            <a:ext cx="1188720" cy="329184"/>
+          </a:xfrm>
+          <a:prstGeom prst="rect">
+            <a:avLst/>
+          </a:prstGeom>
+          <a:solidFill>
+            <a:srgbClr val="E8F0F8"/>
+          </a:solidFill>
+          <a:ln>
+            <a:solidFill>
+              <a:srgbClr val="1F3864"/>
+            </a:solidFill>
+          </a:ln>
+        </p:spPr>
+        <p:style>
+          <a:lnRef idx="1">
+            <a:schemeClr val="accent1"/>
+          </a:lnRef>
+          <a:fillRef idx="3">
+            <a:schemeClr val="accent1"/>
+          </a:fillRef>
+          <a:effectRef idx="2">
+            <a:schemeClr val="accent1"/>
+          </a:effectRef>
+          <a:fontRef idx="minor">
+            <a:schemeClr val="lt1"/>
+          </a:fontRef>
+        </p:style>
+        <p:txBody>
+          <a:bodyPr rtlCol="0" anchor="ctr"/>
+          <a:lstStyle/>
+          <a:p>
+            <a:pPr algn="ctr"/>
+            <a:r>
+              <a:rPr sz="1300" b="0">
+                <a:solidFill>
+                  <a:srgbClr val="444444"/>
+                </a:solidFill>
+              </a:rPr>
+              <a:t>Empty ref</a:t>
+            </a:r>
+          </a:p>
+        </p:txBody>
+      </p:sp>
+      <p:sp>
+        <p:nvSpPr>
+          <p:cNvPr id="31" name="Rectangle 30"/>
+          <p:cNvSpPr/>
+          <p:nvPr/>
+        </p:nvSpPr>
+        <p:spPr>
+          <a:xfrm>
+            <a:off x="3566160" y="2779776"/>
+            <a:ext cx="685800" cy="329184"/>
+          </a:xfrm>
+          <a:prstGeom prst="rect">
+            <a:avLst/>
+          </a:prstGeom>
+          <a:solidFill>
+            <a:srgbClr val="E8F0F8"/>
+          </a:solidFill>
+          <a:ln>
+            <a:solidFill>
+              <a:srgbClr val="1F3864"/>
+            </a:solidFill>
+          </a:ln>
+        </p:spPr>
+        <p:style>
+          <a:lnRef idx="1">
+            <a:schemeClr val="accent1"/>
+          </a:lnRef>
+          <a:fillRef idx="3">
+            <a:schemeClr val="accent1"/>
+          </a:fillRef>
+          <a:effectRef idx="2">
+            <a:schemeClr val="accent1"/>
+          </a:effectRef>
+          <a:fontRef idx="minor">
+            <a:schemeClr val="lt1"/>
+          </a:fontRef>
+        </p:style>
+        <p:txBody>
+          <a:bodyPr rtlCol="0" anchor="ctr"/>
+          <a:lstStyle/>
+          <a:p>
+            <a:pPr algn="ctr"/>
+            <a:r>
+              <a:rPr sz="1300" b="0">
+                <a:solidFill>
+                  <a:srgbClr val="444444"/>
+                </a:solidFill>
+              </a:rPr>
+              <a:t>0</a:t>
+            </a:r>
+          </a:p>
+        </p:txBody>
+      </p:sp>
+      <p:sp>
+        <p:nvSpPr>
+          <p:cNvPr id="32" name="Rectangle 31"/>
+          <p:cNvSpPr/>
+          <p:nvPr/>
+        </p:nvSpPr>
+        <p:spPr>
+          <a:xfrm>
+            <a:off x="4251960" y="2779776"/>
+            <a:ext cx="685800" cy="329184"/>
+          </a:xfrm>
+          <a:prstGeom prst="rect">
+            <a:avLst/>
+          </a:prstGeom>
+          <a:solidFill>
+            <a:srgbClr val="E8F0F8"/>
+          </a:solidFill>
+          <a:ln>
+            <a:solidFill>
+              <a:srgbClr val="1F3864"/>
+            </a:solidFill>
+          </a:ln>
+        </p:spPr>
+        <p:style>
+          <a:lnRef idx="1">
+            <a:schemeClr val="accent1"/>
+          </a:lnRef>
+          <a:fillRef idx="3">
+            <a:schemeClr val="accent1"/>
+          </a:fillRef>
+          <a:effectRef idx="2">
+            <a:schemeClr val="accent1"/>
+          </a:effectRef>
+          <a:fontRef idx="minor">
+            <a:schemeClr val="lt1"/>
+          </a:fontRef>
+        </p:style>
+        <p:txBody>
+          <a:bodyPr rtlCol="0" anchor="ctr"/>
+          <a:lstStyle/>
+          <a:p>
+            <a:pPr algn="ctr"/>
+            <a:r>
+              <a:rPr sz="1300" b="0">
+                <a:solidFill>
+                  <a:srgbClr val="444444"/>
+                </a:solidFill>
+              </a:rPr>
+              <a:t>257</a:t>
+            </a:r>
+          </a:p>
+        </p:txBody>
+      </p:sp>
+      <p:sp>
+        <p:nvSpPr>
+          <p:cNvPr id="33" name="Rectangle 32"/>
+          <p:cNvSpPr/>
+          <p:nvPr/>
+        </p:nvSpPr>
+        <p:spPr>
+          <a:xfrm>
+            <a:off x="4937760" y="2779776"/>
+            <a:ext cx="777240" cy="329184"/>
+          </a:xfrm>
+          <a:prstGeom prst="rect">
+            <a:avLst/>
+          </a:prstGeom>
+          <a:solidFill>
+            <a:srgbClr val="E8F0F8"/>
+          </a:solidFill>
+          <a:ln>
+            <a:solidFill>
+              <a:srgbClr val="1F3864"/>
+            </a:solidFill>
+          </a:ln>
+        </p:spPr>
+        <p:style>
+          <a:lnRef idx="1">
+            <a:schemeClr val="accent1"/>
+          </a:lnRef>
+          <a:fillRef idx="3">
+            <a:schemeClr val="accent1"/>
+          </a:fillRef>
+          <a:effectRef idx="2">
+            <a:schemeClr val="accent1"/>
+          </a:effectRef>
+          <a:fontRef idx="minor">
+            <a:schemeClr val="lt1"/>
+          </a:fontRef>
+        </p:style>
+        <p:txBody>
+          <a:bodyPr rtlCol="0" anchor="ctr"/>
+          <a:lstStyle/>
+          <a:p>
+            <a:pPr algn="ctr"/>
+            <a:r>
+              <a:rPr sz="1300" b="0">
+                <a:solidFill>
+                  <a:srgbClr val="444444"/>
+                </a:solidFill>
+              </a:rPr>
+              <a:t>257</a:t>
+            </a:r>
+          </a:p>
+        </p:txBody>
+      </p:sp>
+      <p:sp>
+        <p:nvSpPr>
+          <p:cNvPr id="34" name="Rectangle 33"/>
+          <p:cNvSpPr/>
+          <p:nvPr/>
+        </p:nvSpPr>
+        <p:spPr>
+          <a:xfrm>
+            <a:off x="365760" y="3108960"/>
+            <a:ext cx="1005840" cy="329184"/>
+          </a:xfrm>
+          <a:prstGeom prst="rect">
+            <a:avLst/>
+          </a:prstGeom>
+          <a:solidFill>
+            <a:srgbClr val="FFFFFF"/>
+          </a:solidFill>
+          <a:ln>
+            <a:solidFill>
+              <a:srgbClr val="1F3864"/>
+            </a:solidFill>
+          </a:ln>
+        </p:spPr>
+        <p:style>
+          <a:lnRef idx="1">
+            <a:schemeClr val="accent1"/>
+          </a:lnRef>
+          <a:fillRef idx="3">
+            <a:schemeClr val="accent1"/>
+          </a:fillRef>
+          <a:effectRef idx="2">
+            <a:schemeClr val="accent1"/>
+          </a:effectRef>
+          <a:fontRef idx="minor">
+            <a:schemeClr val="lt1"/>
+          </a:fontRef>
+        </p:style>
+        <p:txBody>
+          <a:bodyPr rtlCol="0" anchor="ctr"/>
+          <a:lstStyle/>
+          <a:p>
+            <a:pPr algn="ctr"/>
+            <a:r>
+              <a:rPr sz="1300" b="0">
+                <a:solidFill>
+                  <a:srgbClr val="444444"/>
+                </a:solidFill>
+              </a:rPr>
+              <a:t>UFPR2</a:t>
+            </a:r>
+          </a:p>
+        </p:txBody>
+      </p:sp>
+      <p:sp>
+        <p:nvSpPr>
+          <p:cNvPr id="35" name="Rectangle 34"/>
+          <p:cNvSpPr/>
+          <p:nvPr/>
+        </p:nvSpPr>
+        <p:spPr>
+          <a:xfrm>
+            <a:off x="1371600" y="3108960"/>
+            <a:ext cx="1005840" cy="329184"/>
+          </a:xfrm>
+          <a:prstGeom prst="rect">
+            <a:avLst/>
+          </a:prstGeom>
+          <a:solidFill>
+            <a:srgbClr val="FFFFFF"/>
+          </a:solidFill>
+          <a:ln>
+            <a:solidFill>
+              <a:srgbClr val="1F3864"/>
+            </a:solidFill>
+          </a:ln>
+        </p:spPr>
+        <p:style>
+          <a:lnRef idx="1">
+            <a:schemeClr val="accent1"/>
+          </a:lnRef>
+          <a:fillRef idx="3">
+            <a:schemeClr val="accent1"/>
+          </a:fillRef>
+          <a:effectRef idx="2">
+            <a:schemeClr val="accent1"/>
+          </a:effectRef>
+          <a:fontRef idx="minor">
+            <a:schemeClr val="lt1"/>
+          </a:fontRef>
+        </p:style>
+        <p:txBody>
+          <a:bodyPr rtlCol="0" anchor="ctr"/>
+          <a:lstStyle/>
+          <a:p>
+            <a:pPr algn="ctr"/>
+            <a:r>
+              <a:rPr sz="1300" b="0">
+                <a:solidFill>
+                  <a:srgbClr val="444444"/>
+                </a:solidFill>
+              </a:rPr>
+              <a:t>UFPR04</a:t>
+            </a:r>
+          </a:p>
+        </p:txBody>
+      </p:sp>
+      <p:sp>
+        <p:nvSpPr>
+          <p:cNvPr id="36" name="Rectangle 35"/>
+          <p:cNvSpPr/>
+          <p:nvPr/>
+        </p:nvSpPr>
+        <p:spPr>
+          <a:xfrm>
+            <a:off x="2377440" y="3108960"/>
+            <a:ext cx="1188720" cy="329184"/>
+          </a:xfrm>
+          <a:prstGeom prst="rect">
+            <a:avLst/>
+          </a:prstGeom>
+          <a:solidFill>
+            <a:srgbClr val="FFFFFF"/>
+          </a:solidFill>
+          <a:ln>
+            <a:solidFill>
+              <a:srgbClr val="1F3864"/>
+            </a:solidFill>
+          </a:ln>
+        </p:spPr>
+        <p:style>
+          <a:lnRef idx="1">
+            <a:schemeClr val="accent1"/>
+          </a:lnRef>
+          <a:fillRef idx="3">
+            <a:schemeClr val="accent1"/>
+          </a:fillRef>
+          <a:effectRef idx="2">
+            <a:schemeClr val="accent1"/>
+          </a:effectRef>
+          <a:fontRef idx="minor">
+            <a:schemeClr val="lt1"/>
+          </a:fontRef>
+        </p:style>
+        <p:txBody>
+          <a:bodyPr rtlCol="0" anchor="ctr"/>
+          <a:lstStyle/>
+          <a:p>
+            <a:pPr algn="ctr"/>
+            <a:r>
+              <a:rPr sz="1300" b="0">
+                <a:solidFill>
+                  <a:srgbClr val="444444"/>
+                </a:solidFill>
+              </a:rPr>
+              <a:t>Partial</a:t>
+            </a:r>
+          </a:p>
+        </p:txBody>
+      </p:sp>
+      <p:sp>
+        <p:nvSpPr>
+          <p:cNvPr id="37" name="Rectangle 36"/>
+          <p:cNvSpPr/>
+          <p:nvPr/>
+        </p:nvSpPr>
+        <p:spPr>
+          <a:xfrm>
+            <a:off x="3566160" y="3108960"/>
+            <a:ext cx="685800" cy="329184"/>
+          </a:xfrm>
+          <a:prstGeom prst="rect">
+            <a:avLst/>
+          </a:prstGeom>
+          <a:solidFill>
+            <a:srgbClr val="FFFFFF"/>
+          </a:solidFill>
+          <a:ln>
+            <a:solidFill>
+              <a:srgbClr val="1F3864"/>
+            </a:solidFill>
+          </a:ln>
+        </p:spPr>
+        <p:style>
+          <a:lnRef idx="1">
+            <a:schemeClr val="accent1"/>
+          </a:lnRef>
+          <a:fillRef idx="3">
+            <a:schemeClr val="accent1"/>
+          </a:fillRef>
+          <a:effectRef idx="2">
+            <a:schemeClr val="accent1"/>
+          </a:effectRef>
+          <a:fontRef idx="minor">
+            <a:schemeClr val="lt1"/>
+          </a:fontRef>
+        </p:style>
+        <p:txBody>
+          <a:bodyPr rtlCol="0" anchor="ctr"/>
+          <a:lstStyle/>
+          <a:p>
+            <a:pPr algn="ctr"/>
+            <a:r>
+              <a:rPr sz="1300" b="0">
+                <a:solidFill>
+                  <a:srgbClr val="444444"/>
+                </a:solidFill>
+              </a:rPr>
+              <a:t>120</a:t>
+            </a:r>
+          </a:p>
+        </p:txBody>
+      </p:sp>
+      <p:sp>
+        <p:nvSpPr>
+          <p:cNvPr id="38" name="Rectangle 37"/>
+          <p:cNvSpPr/>
+          <p:nvPr/>
+        </p:nvSpPr>
+        <p:spPr>
+          <a:xfrm>
+            <a:off x="4251960" y="3108960"/>
+            <a:ext cx="685800" cy="329184"/>
+          </a:xfrm>
+          <a:prstGeom prst="rect">
+            <a:avLst/>
+          </a:prstGeom>
+          <a:solidFill>
+            <a:srgbClr val="FFFFFF"/>
+          </a:solidFill>
+          <a:ln>
+            <a:solidFill>
+              <a:srgbClr val="1F3864"/>
+            </a:solidFill>
+          </a:ln>
+        </p:spPr>
+        <p:style>
+          <a:lnRef idx="1">
+            <a:schemeClr val="accent1"/>
+          </a:lnRef>
+          <a:fillRef idx="3">
+            <a:schemeClr val="accent1"/>
+          </a:fillRef>
+          <a:effectRef idx="2">
+            <a:schemeClr val="accent1"/>
+          </a:effectRef>
+          <a:fontRef idx="minor">
+            <a:schemeClr val="lt1"/>
+          </a:fontRef>
+        </p:style>
+        <p:txBody>
+          <a:bodyPr rtlCol="0" anchor="ctr"/>
+          <a:lstStyle/>
+          <a:p>
+            <a:pPr algn="ctr"/>
+            <a:r>
+              <a:rPr sz="1300" b="0">
+                <a:solidFill>
+                  <a:srgbClr val="444444"/>
+                </a:solidFill>
+              </a:rPr>
+              <a:t>137</a:t>
+            </a:r>
+          </a:p>
+        </p:txBody>
+      </p:sp>
+      <p:sp>
+        <p:nvSpPr>
+          <p:cNvPr id="39" name="Rectangle 38"/>
+          <p:cNvSpPr/>
+          <p:nvPr/>
+        </p:nvSpPr>
+        <p:spPr>
+          <a:xfrm>
+            <a:off x="4937760" y="3108960"/>
+            <a:ext cx="777240" cy="329184"/>
+          </a:xfrm>
+          <a:prstGeom prst="rect">
+            <a:avLst/>
+          </a:prstGeom>
+          <a:solidFill>
+            <a:srgbClr val="FFFFFF"/>
+          </a:solidFill>
+          <a:ln>
+            <a:solidFill>
+              <a:srgbClr val="1F3864"/>
+            </a:solidFill>
+          </a:ln>
+        </p:spPr>
+        <p:style>
+          <a:lnRef idx="1">
+            <a:schemeClr val="accent1"/>
+          </a:lnRef>
+          <a:fillRef idx="3">
+            <a:schemeClr val="accent1"/>
+          </a:fillRef>
+          <a:effectRef idx="2">
+            <a:schemeClr val="accent1"/>
+          </a:effectRef>
+          <a:fontRef idx="minor">
+            <a:schemeClr val="lt1"/>
+          </a:fontRef>
+        </p:style>
+        <p:txBody>
+          <a:bodyPr rtlCol="0" anchor="ctr"/>
+          <a:lstStyle/>
+          <a:p>
+            <a:pPr algn="ctr"/>
+            <a:r>
+              <a:rPr sz="1300" b="0">
+                <a:solidFill>
+                  <a:srgbClr val="444444"/>
+                </a:solidFill>
+              </a:rPr>
+              <a:t>257</a:t>
+            </a:r>
+          </a:p>
+        </p:txBody>
+      </p:sp>
+      <p:sp>
+        <p:nvSpPr>
+          <p:cNvPr id="40" name="Rectangle 39"/>
+          <p:cNvSpPr/>
+          <p:nvPr/>
+        </p:nvSpPr>
+        <p:spPr>
+          <a:xfrm>
+            <a:off x="365760" y="3438144"/>
+            <a:ext cx="1005840" cy="329184"/>
+          </a:xfrm>
+          <a:prstGeom prst="rect">
+            <a:avLst/>
+          </a:prstGeom>
+          <a:solidFill>
+            <a:srgbClr val="E8F0F8"/>
+          </a:solidFill>
+          <a:ln>
+            <a:solidFill>
+              <a:srgbClr val="1F3864"/>
+            </a:solidFill>
+          </a:ln>
+        </p:spPr>
+        <p:style>
+          <a:lnRef idx="1">
+            <a:schemeClr val="accent1"/>
+          </a:lnRef>
+          <a:fillRef idx="3">
+            <a:schemeClr val="accent1"/>
+          </a:fillRef>
+          <a:effectRef idx="2">
+            <a:schemeClr val="accent1"/>
+          </a:effectRef>
+          <a:fontRef idx="minor">
+            <a:schemeClr val="lt1"/>
+          </a:fontRef>
+        </p:style>
+        <p:txBody>
+          <a:bodyPr rtlCol="0" anchor="ctr"/>
+          <a:lstStyle/>
+          <a:p>
+            <a:pPr algn="ctr"/>
+            <a:r>
+              <a:rPr sz="1300" b="0">
+                <a:solidFill>
+                  <a:srgbClr val="444444"/>
+                </a:solidFill>
+              </a:rPr>
+              <a:t>UFPR3</a:t>
+            </a:r>
+          </a:p>
+        </p:txBody>
+      </p:sp>
+      <p:sp>
+        <p:nvSpPr>
+          <p:cNvPr id="41" name="Rectangle 40"/>
+          <p:cNvSpPr/>
+          <p:nvPr/>
+        </p:nvSpPr>
+        <p:spPr>
+          <a:xfrm>
+            <a:off x="1371600" y="3438144"/>
+            <a:ext cx="1005840" cy="329184"/>
+          </a:xfrm>
+          <a:prstGeom prst="rect">
+            <a:avLst/>
+          </a:prstGeom>
+          <a:solidFill>
+            <a:srgbClr val="E8F0F8"/>
+          </a:solidFill>
+          <a:ln>
+            <a:solidFill>
+              <a:srgbClr val="1F3864"/>
+            </a:solidFill>
+          </a:ln>
+        </p:spPr>
+        <p:style>
+          <a:lnRef idx="1">
+            <a:schemeClr val="accent1"/>
+          </a:lnRef>
+          <a:fillRef idx="3">
+            <a:schemeClr val="accent1"/>
+          </a:fillRef>
+          <a:effectRef idx="2">
+            <a:schemeClr val="accent1"/>
+          </a:effectRef>
+          <a:fontRef idx="minor">
+            <a:schemeClr val="lt1"/>
+          </a:fontRef>
+        </p:style>
+        <p:txBody>
+          <a:bodyPr rtlCol="0" anchor="ctr"/>
+          <a:lstStyle/>
+          <a:p>
+            <a:pPr algn="ctr"/>
+            <a:r>
+              <a:rPr sz="1300" b="0">
+                <a:solidFill>
+                  <a:srgbClr val="444444"/>
+                </a:solidFill>
+              </a:rPr>
+              <a:t>UFPR04</a:t>
+            </a:r>
+          </a:p>
+        </p:txBody>
+      </p:sp>
+      <p:sp>
+        <p:nvSpPr>
+          <p:cNvPr id="42" name="Rectangle 41"/>
+          <p:cNvSpPr/>
+          <p:nvPr/>
+        </p:nvSpPr>
+        <p:spPr>
+          <a:xfrm>
+            <a:off x="2377440" y="3438144"/>
+            <a:ext cx="1188720" cy="329184"/>
+          </a:xfrm>
+          <a:prstGeom prst="rect">
+            <a:avLst/>
+          </a:prstGeom>
+          <a:solidFill>
+            <a:srgbClr val="E8F0F8"/>
+          </a:solidFill>
+          <a:ln>
+            <a:solidFill>
+              <a:srgbClr val="1F3864"/>
+            </a:solidFill>
+          </a:ln>
+        </p:spPr>
+        <p:style>
+          <a:lnRef idx="1">
+            <a:schemeClr val="accent1"/>
+          </a:lnRef>
+          <a:fillRef idx="3">
+            <a:schemeClr val="accent1"/>
+          </a:fillRef>
+          <a:effectRef idx="2">
+            <a:schemeClr val="accent1"/>
+          </a:effectRef>
+          <a:fontRef idx="minor">
+            <a:schemeClr val="lt1"/>
+          </a:fontRef>
+        </p:style>
+        <p:txBody>
+          <a:bodyPr rtlCol="0" anchor="ctr"/>
+          <a:lstStyle/>
+          <a:p>
+            <a:pPr algn="ctr"/>
+            <a:r>
+              <a:rPr sz="1300" b="0">
+                <a:solidFill>
+                  <a:srgbClr val="444444"/>
+                </a:solidFill>
+              </a:rPr>
+              <a:t>Heavy</a:t>
+            </a:r>
+          </a:p>
+        </p:txBody>
+      </p:sp>
+      <p:sp>
+        <p:nvSpPr>
+          <p:cNvPr id="43" name="Rectangle 42"/>
+          <p:cNvSpPr/>
+          <p:nvPr/>
+        </p:nvSpPr>
+        <p:spPr>
+          <a:xfrm>
+            <a:off x="3566160" y="3438144"/>
+            <a:ext cx="685800" cy="329184"/>
+          </a:xfrm>
+          <a:prstGeom prst="rect">
+            <a:avLst/>
+          </a:prstGeom>
+          <a:solidFill>
+            <a:srgbClr val="E8F0F8"/>
+          </a:solidFill>
+          <a:ln>
+            <a:solidFill>
+              <a:srgbClr val="1F3864"/>
+            </a:solidFill>
+          </a:ln>
+        </p:spPr>
+        <p:style>
+          <a:lnRef idx="1">
+            <a:schemeClr val="accent1"/>
+          </a:lnRef>
+          <a:fillRef idx="3">
+            <a:schemeClr val="accent1"/>
+          </a:fillRef>
+          <a:effectRef idx="2">
+            <a:schemeClr val="accent1"/>
+          </a:effectRef>
+          <a:fontRef idx="minor">
+            <a:schemeClr val="lt1"/>
+          </a:fontRef>
+        </p:style>
+        <p:txBody>
+          <a:bodyPr rtlCol="0" anchor="ctr"/>
+          <a:lstStyle/>
+          <a:p>
+            <a:pPr algn="ctr"/>
+            <a:r>
+              <a:rPr sz="1300" b="0">
+                <a:solidFill>
+                  <a:srgbClr val="444444"/>
+                </a:solidFill>
+              </a:rPr>
+              <a:t>212</a:t>
+            </a:r>
+          </a:p>
+        </p:txBody>
+      </p:sp>
+      <p:sp>
+        <p:nvSpPr>
+          <p:cNvPr id="44" name="Rectangle 43"/>
+          <p:cNvSpPr/>
+          <p:nvPr/>
+        </p:nvSpPr>
+        <p:spPr>
+          <a:xfrm>
+            <a:off x="4251960" y="3438144"/>
+            <a:ext cx="685800" cy="329184"/>
+          </a:xfrm>
+          <a:prstGeom prst="rect">
+            <a:avLst/>
+          </a:prstGeom>
+          <a:solidFill>
+            <a:srgbClr val="E8F0F8"/>
+          </a:solidFill>
+          <a:ln>
+            <a:solidFill>
+              <a:srgbClr val="1F3864"/>
+            </a:solidFill>
+          </a:ln>
+        </p:spPr>
+        <p:style>
+          <a:lnRef idx="1">
+            <a:schemeClr val="accent1"/>
+          </a:lnRef>
+          <a:fillRef idx="3">
+            <a:schemeClr val="accent1"/>
+          </a:fillRef>
+          <a:effectRef idx="2">
+            <a:schemeClr val="accent1"/>
+          </a:effectRef>
+          <a:fontRef idx="minor">
+            <a:schemeClr val="lt1"/>
+          </a:fontRef>
+        </p:style>
+        <p:txBody>
+          <a:bodyPr rtlCol="0" anchor="ctr"/>
+          <a:lstStyle/>
+          <a:p>
+            <a:pPr algn="ctr"/>
+            <a:r>
+              <a:rPr sz="1300" b="0">
+                <a:solidFill>
+                  <a:srgbClr val="444444"/>
+                </a:solidFill>
+              </a:rPr>
+              <a:t>45</a:t>
+            </a:r>
+          </a:p>
+        </p:txBody>
+      </p:sp>
+      <p:sp>
+        <p:nvSpPr>
+          <p:cNvPr id="45" name="Rectangle 44"/>
+          <p:cNvSpPr/>
+          <p:nvPr/>
+        </p:nvSpPr>
+        <p:spPr>
+          <a:xfrm>
+            <a:off x="4937760" y="3438144"/>
+            <a:ext cx="777240" cy="329184"/>
+          </a:xfrm>
+          <a:prstGeom prst="rect">
+            <a:avLst/>
+          </a:prstGeom>
+          <a:solidFill>
+            <a:srgbClr val="E8F0F8"/>
+          </a:solidFill>
+          <a:ln>
+            <a:solidFill>
+              <a:srgbClr val="1F3864"/>
+            </a:solidFill>
+          </a:ln>
+        </p:spPr>
+        <p:style>
+          <a:lnRef idx="1">
+            <a:schemeClr val="accent1"/>
+          </a:lnRef>
+          <a:fillRef idx="3">
+            <a:schemeClr val="accent1"/>
+          </a:fillRef>
+          <a:effectRef idx="2">
+            <a:schemeClr val="accent1"/>
+          </a:effectRef>
+          <a:fontRef idx="minor">
+            <a:schemeClr val="lt1"/>
+          </a:fontRef>
+        </p:style>
+        <p:txBody>
+          <a:bodyPr rtlCol="0" anchor="ctr"/>
+          <a:lstStyle/>
+          <a:p>
+            <a:pPr algn="ctr"/>
+            <a:r>
+              <a:rPr sz="1300" b="0">
+                <a:solidFill>
+                  <a:srgbClr val="444444"/>
+                </a:solidFill>
+              </a:rPr>
+              <a:t>257</a:t>
+            </a:r>
+          </a:p>
+        </p:txBody>
+      </p:sp>
+      <p:sp>
+        <p:nvSpPr>
+          <p:cNvPr id="46" name="Rectangle 45"/>
+          <p:cNvSpPr/>
+          <p:nvPr/>
+        </p:nvSpPr>
+        <p:spPr>
+          <a:xfrm>
+            <a:off x="0" y="0"/>
+            <a:ext cx="12188952" cy="1280160"/>
+          </a:xfrm>
+          <a:prstGeom prst="rect">
+            <a:avLst/>
+          </a:prstGeom>
+          <a:solidFill>
+            <a:srgbClr val="1F3864"/>
+          </a:solidFill>
+          <a:ln>
+            <a:noFill/>
+          </a:ln>
+        </p:spPr>
+        <p:style>
+          <a:lnRef idx="1">
+            <a:schemeClr val="accent1"/>
+          </a:lnRef>
+          <a:fillRef idx="3">
+            <a:schemeClr val="accent1"/>
+          </a:fillRef>
+          <a:effectRef idx="2">
+            <a:schemeClr val="accent1"/>
+          </a:effectRef>
+          <a:fontRef idx="minor">
+            <a:schemeClr val="lt1"/>
+          </a:fontRef>
+        </p:style>
+        <p:txBody>
+          <a:bodyPr rtlCol="0" anchor="ctr"/>
+          <a:lstStyle/>
+          <a:p>
+            <a:pPr algn="ctr"/>
+          </a:p>
+        </p:txBody>
+      </p:sp>
+      <p:sp>
+        <p:nvSpPr>
+          <p:cNvPr id="47" name="TextBox 46"/>
+          <p:cNvSpPr txBox="1"/>
+          <p:nvPr/>
+        </p:nvSpPr>
+        <p:spPr>
+          <a:xfrm>
+            <a:off x="274320" y="91440"/>
+            <a:ext cx="11612880" cy="731520"/>
+          </a:xfrm>
+          <a:prstGeom prst="rect">
+            <a:avLst/>
+          </a:prstGeom>
+          <a:noFill/>
+        </p:spPr>
+        <p:txBody>
+          <a:bodyPr wrap="square">
+            <a:spAutoFit/>
+          </a:bodyPr>
+          <a:lstStyle/>
+          <a:p>
+            <a:pPr algn="l"/>
+            <a:r>
+              <a:rPr sz="3200" b="1">
+                <a:solidFill>
+                  <a:srgbClr val="FFFFFF"/>
+                </a:solidFill>
+              </a:rPr>
+              <a:t/>
+            </a:r>
+          </a:p>
+        </p:txBody>
+      </p:sp>
+      <p:sp>
+        <p:nvSpPr>
+          <p:cNvPr id="48" name="TextBox 47"/>
+          <p:cNvSpPr txBox="1"/>
+          <p:nvPr/>
+        </p:nvSpPr>
+        <p:spPr>
+          <a:xfrm>
+            <a:off x="365760" y="3977639"/>
+            <a:ext cx="11430000" cy="502920"/>
+          </a:xfrm>
+          <a:prstGeom prst="rect">
+            <a:avLst/>
+          </a:prstGeom>
+          <a:noFill/>
+        </p:spPr>
+        <p:txBody>
+          <a:bodyPr wrap="square">
+            <a:spAutoFit/>
+          </a:bodyPr>
+          <a:lstStyle/>
+          <a:p>
+            <a:pPr algn="l"/>
+            <a:r>
+              <a:rPr sz="1900" b="0">
+                <a:solidFill>
+                  <a:srgbClr val="444444"/>
+                </a:solidFill>
+              </a:rPr>
+              <a:t>  • Fundamental challenge: edge/σ distributions of empty textured spaces and low-contrast cars overlap</a:t>
+            </a:r>
+          </a:p>
+        </p:txBody>
+      </p:sp>
+      <p:sp>
+        <p:nvSpPr>
+          <p:cNvPr id="49" name="TextBox 48"/>
+          <p:cNvSpPr txBox="1"/>
+          <p:nvPr/>
+        </p:nvSpPr>
+        <p:spPr>
+          <a:xfrm>
+            <a:off x="365760" y="4507991"/>
+            <a:ext cx="11430000" cy="502920"/>
+          </a:xfrm>
+          <a:prstGeom prst="rect">
+            <a:avLst/>
+          </a:prstGeom>
+          <a:noFill/>
+        </p:spPr>
+        <p:txBody>
+          <a:bodyPr wrap="square">
+            <a:spAutoFit/>
+          </a:bodyPr>
+          <a:lstStyle/>
+          <a:p>
+            <a:pPr algn="l"/>
+            <a:r>
+              <a:rPr sz="1900" b="0">
+                <a:solidFill>
+                  <a:srgbClr val="444444"/>
+                </a:solidFill>
+              </a:rPr>
+              <a:t>  • Canny(30,90) tested — empty-space max rose from 127→234, requiring threshold 244 (too high)</a:t>
+            </a:r>
+          </a:p>
+        </p:txBody>
+      </p:sp>
+      <p:sp>
+        <p:nvSpPr>
+          <p:cNvPr id="50" name="TextBox 49"/>
+          <p:cNvSpPr txBox="1"/>
+          <p:nvPr/>
+        </p:nvSpPr>
+        <p:spPr>
+          <a:xfrm>
+            <a:off x="365760" y="5038343"/>
+            <a:ext cx="11430000" cy="502920"/>
+          </a:xfrm>
+          <a:prstGeom prst="rect">
+            <a:avLst/>
+          </a:prstGeom>
+          <a:noFill/>
+        </p:spPr>
+        <p:txBody>
+          <a:bodyPr wrap="square">
+            <a:spAutoFit/>
+          </a:bodyPr>
+          <a:lstStyle/>
+          <a:p>
+            <a:pPr algn="l"/>
+            <a:r>
+              <a:rPr sz="1900" b="0">
+                <a:solidFill>
+                  <a:srgbClr val="444444"/>
+                </a:solidFill>
+              </a:rPr>
+              <a:t>  • Dual-signal OR logic improves recall without increasing false positives on calibration image</a:t>
+            </a:r>
+          </a:p>
+        </p:txBody>
+      </p:sp>
+      <p:sp>
+        <p:nvSpPr>
+          <p:cNvPr id="51" name="TextBox 50"/>
+          <p:cNvSpPr txBox="1"/>
+          <p:nvPr/>
+        </p:nvSpPr>
+        <p:spPr>
+          <a:xfrm>
+            <a:off x="365760" y="5568695"/>
+            <a:ext cx="11430000" cy="502920"/>
+          </a:xfrm>
+          <a:prstGeom prst="rect">
+            <a:avLst/>
+          </a:prstGeom>
+          <a:noFill/>
+        </p:spPr>
+        <p:txBody>
+          <a:bodyPr wrap="square">
+            <a:spAutoFit/>
+          </a:bodyPr>
+          <a:lstStyle/>
+          <a:p>
+            <a:pPr algn="l"/>
+            <a:r>
+              <a:rPr sz="1900" b="0">
+                <a:solidFill>
+                  <a:srgbClr val="444444"/>
+                </a:solidFill>
+              </a:rPr>
+              <a:t>  • Remaining errors are irreducible without a background reference or learned classifier</a:t>
+            </a:r>
+          </a:p>
+        </p:txBody>
+      </p:sp>
+    </p:spTree>
+  </p:cSld>
+  <p:clrMapOvr>
+    <a:masterClrMapping/>
+  </p:clrMapOvr>
+</p:sld>
+</file>
+
+<file path=ppt/slides/slide13.xml><?xml version="1.0" encoding="utf-8"?>
+<p:sld xmlns:a="http://schemas.openxmlformats.org/drawingml/2006/main" xmlns:p="http://schemas.openxmlformats.org/presentationml/2006/main" xmlns:r="http://schemas.openxmlformats.org/officeDocument/2006/relationships">
+  <p:cSld>
+    <p:spTree>
+      <p:nvGrpSpPr>
+        <p:cNvPr id="1" name=""/>
+        <p:cNvGrpSpPr/>
+        <p:nvPr/>
+      </p:nvGrpSpPr>
+      <p:grpSpPr/>
+      <p:sp>
+        <p:nvSpPr>
+          <p:cNvPr id="2" name="Rectangle 1"/>
+          <p:cNvSpPr/>
+          <p:nvPr/>
+        </p:nvSpPr>
+        <p:spPr>
+          <a:xfrm>
+            <a:off x="0" y="0"/>
+            <a:ext cx="12188952" cy="1280160"/>
+          </a:xfrm>
+          <a:prstGeom prst="rect">
+            <a:avLst/>
+          </a:prstGeom>
+          <a:solidFill>
+            <a:srgbClr val="1F3864"/>
+          </a:solidFill>
+          <a:ln>
+            <a:noFill/>
+          </a:ln>
+        </p:spPr>
+        <p:style>
+          <a:lnRef idx="1">
+            <a:schemeClr val="accent1"/>
+          </a:lnRef>
+          <a:fillRef idx="3">
+            <a:schemeClr val="accent1"/>
+          </a:fillRef>
+          <a:effectRef idx="2">
+            <a:schemeClr val="accent1"/>
+          </a:effectRef>
+          <a:fontRef idx="minor">
+            <a:schemeClr val="lt1"/>
+          </a:fontRef>
+        </p:style>
+        <p:txBody>
+          <a:bodyPr rtlCol="0" anchor="ctr"/>
+          <a:lstStyle/>
+          <a:p>
+            <a:pPr algn="ctr"/>
+          </a:p>
+        </p:txBody>
+      </p:sp>
+      <p:sp>
+        <p:nvSpPr>
+          <p:cNvPr id="3" name="TextBox 2"/>
+          <p:cNvSpPr txBox="1"/>
+          <p:nvPr/>
+        </p:nvSpPr>
+        <p:spPr>
+          <a:xfrm>
+            <a:off x="274320" y="91440"/>
+            <a:ext cx="11612880" cy="731520"/>
+          </a:xfrm>
+          <a:prstGeom prst="rect">
+            <a:avLst/>
+          </a:prstGeom>
+          <a:noFill/>
+        </p:spPr>
+        <p:txBody>
+          <a:bodyPr wrap="square">
+            <a:spAutoFit/>
+          </a:bodyPr>
+          <a:lstStyle/>
+          <a:p>
+            <a:pPr algn="l"/>
+            <a:r>
+              <a:rPr sz="3200" b="1">
+                <a:solidFill>
+                  <a:srgbClr val="FFFFFF"/>
+                </a:solidFill>
+              </a:rPr>
+              <a:t>Future Work</a:t>
+            </a:r>
+          </a:p>
+        </p:txBody>
+      </p:sp>
+      <p:sp>
+        <p:nvSpPr>
+          <p:cNvPr id="4" name="TextBox 3"/>
+          <p:cNvSpPr txBox="1"/>
+          <p:nvPr/>
+        </p:nvSpPr>
+        <p:spPr>
+          <a:xfrm>
+            <a:off x="365760" y="1417320"/>
+            <a:ext cx="11430000" cy="502920"/>
+          </a:xfrm>
+          <a:prstGeom prst="rect">
+            <a:avLst/>
+          </a:prstGeom>
+          <a:noFill/>
+        </p:spPr>
+        <p:txBody>
+          <a:bodyPr wrap="square">
+            <a:spAutoFit/>
+          </a:bodyPr>
+          <a:lstStyle/>
+          <a:p>
+            <a:pPr algn="l"/>
+            <a:r>
               <a:rPr sz="2200" b="0">
                 <a:solidFill>
                   <a:srgbClr val="444444"/>
                 </a:solidFill>
               </a:rPr>
+              <a:t>  • Automatic ROI detection via Hough line transform — no manual tracing for new lots</a:t>
+            </a:r>
+          </a:p>
+        </p:txBody>
+      </p:sp>
+      <p:sp>
+        <p:nvSpPr>
+          <p:cNvPr id="5" name="TextBox 4"/>
+          <p:cNvSpPr txBox="1"/>
+          <p:nvPr/>
+        </p:nvSpPr>
+        <p:spPr>
+          <a:xfrm>
+            <a:off x="365760" y="1947672"/>
+            <a:ext cx="11430000" cy="502920"/>
+          </a:xfrm>
+          <a:prstGeom prst="rect">
+            <a:avLst/>
+          </a:prstGeom>
+          <a:noFill/>
+        </p:spPr>
+        <p:txBody>
+          <a:bodyPr wrap="square">
+            <a:spAutoFit/>
+          </a:bodyPr>
+          <a:lstStyle/>
+          <a:p>
+            <a:pPr algn="l"/>
+            <a:r>
+              <a:rPr sz="2200" b="0">
+                <a:solidFill>
+                  <a:srgbClr val="444444"/>
+                </a:solidFill>
+              </a:rPr>
+              <a:t>  • Background subtraction using registered empty-lot reference — eliminate shadow false positives</a:t>
+            </a:r>
+          </a:p>
+        </p:txBody>
+      </p:sp>
+      <p:sp>
+        <p:nvSpPr>
+          <p:cNvPr id="6" name="TextBox 5"/>
+          <p:cNvSpPr txBox="1"/>
+          <p:nvPr/>
+        </p:nvSpPr>
+        <p:spPr>
+          <a:xfrm>
+            <a:off x="365760" y="2478024"/>
+            <a:ext cx="11430000" cy="502920"/>
+          </a:xfrm>
+          <a:prstGeom prst="rect">
+            <a:avLst/>
+          </a:prstGeom>
+          <a:noFill/>
+        </p:spPr>
+        <p:txBody>
+          <a:bodyPr wrap="square">
+            <a:spAutoFit/>
+          </a:bodyPr>
+          <a:lstStyle/>
+          <a:p>
+            <a:pPr algn="l"/>
+            <a:r>
+              <a:rPr sz="2200" b="0">
+                <a:solidFill>
+                  <a:srgbClr val="444444"/>
+                </a:solidFill>
+              </a:rPr>
               <a:t>  • Live video mode using cv::VideoCapture — real-time occupancy monitoring with FPS display</a:t>
             </a:r>
           </a:p>
@@ -3509,13 +6318,13 @@
       </p:sp>
       <p:sp>
         <p:nvSpPr>
-          <p:cNvPr id="8" name="TextBox 7"/>
+          <p:cNvPr id="7" name="TextBox 6"/>
           <p:cNvSpPr txBox="1"/>
           <p:nvPr/>
         </p:nvSpPr>
         <p:spPr>
           <a:xfrm>
-            <a:off x="365760" y="3538728"/>
+            <a:off x="365760" y="3008376"/>
             <a:ext cx="11430000" cy="502920"/>
           </a:xfrm>
           <a:prstGeom prst="rect">
@@ -3767,7 +6576,7 @@
                   <a:srgbClr val="444444"/>
                 </a:solidFill>
               </a:rPr>
-              <a:t>  • Dataset: PKLot — overhead images from PUCPR (Brazil) under varied lighting and occupancy conditions</a:t>
+              <a:t>  • Dataset: PKLot — overhead images from PUCPR and UFPR04 (Brazil) under varied lighting and occupancy conditions</a:t>
             </a:r>
           </a:p>
         </p:txBody>
@@ -5171,7 +7980,7 @@
                   <a:srgbClr val="FFFFFF"/>
                 </a:solidFill>
               </a:rPr>
-              <a:t>ROI Definition — PUCPR Lot</a:t>
+              <a:t>ROI Definition — Both Lots</a:t>
             </a:r>
           </a:p>
         </p:txBody>
@@ -5205,7 +8014,7 @@
                   <a:srgbClr val="444444"/>
                 </a:solidFill>
               </a:rPr>
-              <a:t>  • 43 parking spaces defined as quadrilateral polygons (not axis-aligned rectangles)</a:t>
+              <a:t>  • Each space defined as a quadrilateral polygon — four corner points clicked interactively</a:t>
             </a:r>
           </a:p>
         </p:txBody>
@@ -5239,7 +8048,7 @@
                   <a:srgbClr val="444444"/>
                 </a:solidFill>
               </a:rPr>
-              <a:t>  • PUCPR spaces are diagonally angled — polygons trace the actual painted boundaries</a:t>
+              <a:t>  • Custom OpenCV label tool: click 4 corners → auto-completes polygon → press S to export code</a:t>
             </a:r>
           </a:p>
         </p:txBody>
@@ -5273,7 +8082,7 @@
                   <a:srgbClr val="444444"/>
                 </a:solidFill>
               </a:rPr>
-              <a:t>  • Polygons traced interactively using a custom OpenCV mouse-callback coordinate tool</a:t>
+              <a:t>  • Polygon mask (cv::fillConvexPoly) ensures classification uses only interior pixels</a:t>
             </a:r>
           </a:p>
         </p:txBody>
@@ -5307,7 +8116,7 @@
                   <a:srgbClr val="444444"/>
                 </a:solidFill>
               </a:rPr>
-              <a:t>  • Polygon mask (cv::fillConvexPoly) ensures classification uses only interior pixels</a:t>
+              <a:t>  • ROIs placed inside painted lines to avoid line-marking edges inflating edge counts</a:t>
             </a:r>
           </a:p>
         </p:txBody>
@@ -5341,7 +8150,7 @@
                   <a:srgbClr val="444444"/>
                 </a:solidFill>
               </a:rPr>
-              <a:t>  • ROIs placed inside painted lines to avoid line-marking edges inflating edge counts</a:t>
+              <a:t>  • PUCPR: 43 spaces  |  UFPR04: 257 spaces</a:t>
             </a:r>
           </a:p>
         </p:txBody>
@@ -5375,7 +8184,7 @@
                   <a:srgbClr val="444444"/>
                 </a:solidFill>
               </a:rPr>
-              <a:t>  • Calibration image: PUCPR3.jpg (empty lot) — zero false positives achieved</a:t>
+              <a:t>  • Calibration: PUCPR3.jpg and UFPR1.jpg (empty references) — zero false positives on both</a:t>
             </a:r>
           </a:p>
         </p:txBody>
@@ -5929,1124 +8738,45 @@
                   <a:srgbClr val="FFFFFF"/>
                 </a:solidFill>
               </a:rPr>
-              <a:t>Accuracy Summary &amp; Challenges</a:t>
-            </a:r>
-          </a:p>
-        </p:txBody>
-      </p:sp>
-      <p:sp>
-        <p:nvSpPr>
-          <p:cNvPr id="4" name="Rectangle 3"/>
-          <p:cNvSpPr/>
-          <p:nvPr/>
-        </p:nvSpPr>
-        <p:spPr>
-          <a:xfrm>
-            <a:off x="365760" y="1463040"/>
-            <a:ext cx="1097280" cy="384048"/>
-          </a:xfrm>
-          <a:prstGeom prst="rect">
-            <a:avLst/>
-          </a:prstGeom>
-          <a:solidFill>
-            <a:srgbClr val="1F3864"/>
-          </a:solidFill>
-          <a:ln>
-            <a:solidFill>
-              <a:srgbClr val="1F3864"/>
-            </a:solidFill>
-          </a:ln>
-        </p:spPr>
-        <p:style>
-          <a:lnRef idx="1">
-            <a:schemeClr val="accent1"/>
-          </a:lnRef>
-          <a:fillRef idx="3">
-            <a:schemeClr val="accent1"/>
-          </a:fillRef>
-          <a:effectRef idx="2">
-            <a:schemeClr val="accent1"/>
-          </a:effectRef>
-          <a:fontRef idx="minor">
-            <a:schemeClr val="lt1"/>
-          </a:fontRef>
-        </p:style>
-        <p:txBody>
-          <a:bodyPr rtlCol="0" anchor="ctr"/>
-          <a:lstStyle/>
-          <a:p>
-            <a:pPr algn="ctr"/>
-            <a:r>
-              <a:rPr sz="1400" b="1">
-                <a:solidFill>
-                  <a:srgbClr val="FFFFFF"/>
-                </a:solidFill>
-              </a:rPr>
-              <a:t>Image</a:t>
-            </a:r>
-          </a:p>
-        </p:txBody>
-      </p:sp>
-      <p:sp>
-        <p:nvSpPr>
-          <p:cNvPr id="5" name="Rectangle 4"/>
-          <p:cNvSpPr/>
-          <p:nvPr/>
-        </p:nvSpPr>
-        <p:spPr>
-          <a:xfrm>
-            <a:off x="1463040" y="1463040"/>
-            <a:ext cx="1371600" cy="384048"/>
-          </a:xfrm>
-          <a:prstGeom prst="rect">
-            <a:avLst/>
-          </a:prstGeom>
-          <a:solidFill>
-            <a:srgbClr val="1F3864"/>
-          </a:solidFill>
-          <a:ln>
-            <a:solidFill>
-              <a:srgbClr val="1F3864"/>
-            </a:solidFill>
-          </a:ln>
-        </p:spPr>
-        <p:style>
-          <a:lnRef idx="1">
-            <a:schemeClr val="accent1"/>
-          </a:lnRef>
-          <a:fillRef idx="3">
-            <a:schemeClr val="accent1"/>
-          </a:fillRef>
-          <a:effectRef idx="2">
-            <a:schemeClr val="accent1"/>
-          </a:effectRef>
-          <a:fontRef idx="minor">
-            <a:schemeClr val="lt1"/>
-          </a:fontRef>
-        </p:style>
-        <p:txBody>
-          <a:bodyPr rtlCol="0" anchor="ctr"/>
-          <a:lstStyle/>
-          <a:p>
-            <a:pPr algn="ctr"/>
-            <a:r>
-              <a:rPr sz="1400" b="1">
-                <a:solidFill>
-                  <a:srgbClr val="FFFFFF"/>
-                </a:solidFill>
-              </a:rPr>
-              <a:t>Condition</a:t>
-            </a:r>
-          </a:p>
-        </p:txBody>
-      </p:sp>
-      <p:sp>
-        <p:nvSpPr>
-          <p:cNvPr id="6" name="Rectangle 5"/>
-          <p:cNvSpPr/>
-          <p:nvPr/>
-        </p:nvSpPr>
-        <p:spPr>
-          <a:xfrm>
-            <a:off x="2834640" y="1463040"/>
-            <a:ext cx="731520" cy="384048"/>
-          </a:xfrm>
-          <a:prstGeom prst="rect">
-            <a:avLst/>
-          </a:prstGeom>
-          <a:solidFill>
-            <a:srgbClr val="1F3864"/>
-          </a:solidFill>
-          <a:ln>
-            <a:solidFill>
-              <a:srgbClr val="1F3864"/>
-            </a:solidFill>
-          </a:ln>
-        </p:spPr>
-        <p:style>
-          <a:lnRef idx="1">
-            <a:schemeClr val="accent1"/>
-          </a:lnRef>
-          <a:fillRef idx="3">
-            <a:schemeClr val="accent1"/>
-          </a:fillRef>
-          <a:effectRef idx="2">
-            <a:schemeClr val="accent1"/>
-          </a:effectRef>
-          <a:fontRef idx="minor">
-            <a:schemeClr val="lt1"/>
-          </a:fontRef>
-        </p:style>
-        <p:txBody>
-          <a:bodyPr rtlCol="0" anchor="ctr"/>
-          <a:lstStyle/>
-          <a:p>
-            <a:pPr algn="ctr"/>
-            <a:r>
-              <a:rPr sz="1400" b="1">
-                <a:solidFill>
-                  <a:srgbClr val="FFFFFF"/>
-                </a:solidFill>
-              </a:rPr>
-              <a:t>Occ</a:t>
-            </a:r>
-          </a:p>
-        </p:txBody>
-      </p:sp>
-      <p:sp>
-        <p:nvSpPr>
-          <p:cNvPr id="7" name="Rectangle 6"/>
-          <p:cNvSpPr/>
-          <p:nvPr/>
-        </p:nvSpPr>
-        <p:spPr>
-          <a:xfrm>
-            <a:off x="3566160" y="1463040"/>
-            <a:ext cx="731520" cy="384048"/>
-          </a:xfrm>
-          <a:prstGeom prst="rect">
-            <a:avLst/>
-          </a:prstGeom>
-          <a:solidFill>
-            <a:srgbClr val="1F3864"/>
-          </a:solidFill>
-          <a:ln>
-            <a:solidFill>
-              <a:srgbClr val="1F3864"/>
-            </a:solidFill>
-          </a:ln>
-        </p:spPr>
-        <p:style>
-          <a:lnRef idx="1">
-            <a:schemeClr val="accent1"/>
-          </a:lnRef>
-          <a:fillRef idx="3">
-            <a:schemeClr val="accent1"/>
-          </a:fillRef>
-          <a:effectRef idx="2">
-            <a:schemeClr val="accent1"/>
-          </a:effectRef>
-          <a:fontRef idx="minor">
-            <a:schemeClr val="lt1"/>
-          </a:fontRef>
-        </p:style>
-        <p:txBody>
-          <a:bodyPr rtlCol="0" anchor="ctr"/>
-          <a:lstStyle/>
-          <a:p>
-            <a:pPr algn="ctr"/>
-            <a:r>
-              <a:rPr sz="1400" b="1">
-                <a:solidFill>
-                  <a:srgbClr val="FFFFFF"/>
-                </a:solidFill>
-              </a:rPr>
-              <a:t>Emp</a:t>
-            </a:r>
-          </a:p>
-        </p:txBody>
-      </p:sp>
-      <p:sp>
-        <p:nvSpPr>
-          <p:cNvPr id="8" name="Rectangle 7"/>
-          <p:cNvSpPr/>
-          <p:nvPr/>
-        </p:nvSpPr>
-        <p:spPr>
-          <a:xfrm>
-            <a:off x="4297680" y="1463040"/>
-            <a:ext cx="731520" cy="384048"/>
-          </a:xfrm>
-          <a:prstGeom prst="rect">
-            <a:avLst/>
-          </a:prstGeom>
-          <a:solidFill>
-            <a:srgbClr val="1F3864"/>
-          </a:solidFill>
-          <a:ln>
-            <a:solidFill>
-              <a:srgbClr val="1F3864"/>
-            </a:solidFill>
-          </a:ln>
-        </p:spPr>
-        <p:style>
-          <a:lnRef idx="1">
-            <a:schemeClr val="accent1"/>
-          </a:lnRef>
-          <a:fillRef idx="3">
-            <a:schemeClr val="accent1"/>
-          </a:fillRef>
-          <a:effectRef idx="2">
-            <a:schemeClr val="accent1"/>
-          </a:effectRef>
-          <a:fontRef idx="minor">
-            <a:schemeClr val="lt1"/>
-          </a:fontRef>
-        </p:style>
-        <p:txBody>
-          <a:bodyPr rtlCol="0" anchor="ctr"/>
-          <a:lstStyle/>
-          <a:p>
-            <a:pPr algn="ctr"/>
-            <a:r>
-              <a:rPr sz="1400" b="1">
-                <a:solidFill>
-                  <a:srgbClr val="FFFFFF"/>
-                </a:solidFill>
-              </a:rPr>
-              <a:t>Total</a:t>
-            </a:r>
-          </a:p>
-        </p:txBody>
-      </p:sp>
-      <p:sp>
-        <p:nvSpPr>
-          <p:cNvPr id="9" name="Rectangle 8"/>
-          <p:cNvSpPr/>
-          <p:nvPr/>
-        </p:nvSpPr>
-        <p:spPr>
-          <a:xfrm>
-            <a:off x="365760" y="1847088"/>
-            <a:ext cx="1097280" cy="384048"/>
-          </a:xfrm>
-          <a:prstGeom prst="rect">
-            <a:avLst/>
-          </a:prstGeom>
-          <a:solidFill>
-            <a:srgbClr val="FFFFFF"/>
-          </a:solidFill>
-          <a:ln>
-            <a:solidFill>
-              <a:srgbClr val="1F3864"/>
-            </a:solidFill>
-          </a:ln>
-        </p:spPr>
-        <p:style>
-          <a:lnRef idx="1">
-            <a:schemeClr val="accent1"/>
-          </a:lnRef>
-          <a:fillRef idx="3">
-            <a:schemeClr val="accent1"/>
-          </a:fillRef>
-          <a:effectRef idx="2">
-            <a:schemeClr val="accent1"/>
-          </a:effectRef>
-          <a:fontRef idx="minor">
-            <a:schemeClr val="lt1"/>
-          </a:fontRef>
-        </p:style>
-        <p:txBody>
-          <a:bodyPr rtlCol="0" anchor="ctr"/>
-          <a:lstStyle/>
-          <a:p>
-            <a:pPr algn="ctr"/>
-            <a:r>
-              <a:rPr sz="1400" b="0">
-                <a:solidFill>
-                  <a:srgbClr val="444444"/>
-                </a:solidFill>
-              </a:rPr>
-              <a:t>PUCPR3</a:t>
-            </a:r>
-          </a:p>
-        </p:txBody>
-      </p:sp>
-      <p:sp>
-        <p:nvSpPr>
-          <p:cNvPr id="10" name="Rectangle 9"/>
-          <p:cNvSpPr/>
-          <p:nvPr/>
-        </p:nvSpPr>
-        <p:spPr>
-          <a:xfrm>
-            <a:off x="1463040" y="1847088"/>
-            <a:ext cx="1371600" cy="384048"/>
-          </a:xfrm>
-          <a:prstGeom prst="rect">
-            <a:avLst/>
-          </a:prstGeom>
-          <a:solidFill>
-            <a:srgbClr val="FFFFFF"/>
-          </a:solidFill>
-          <a:ln>
-            <a:solidFill>
-              <a:srgbClr val="1F3864"/>
-            </a:solidFill>
-          </a:ln>
-        </p:spPr>
-        <p:style>
-          <a:lnRef idx="1">
-            <a:schemeClr val="accent1"/>
-          </a:lnRef>
-          <a:fillRef idx="3">
-            <a:schemeClr val="accent1"/>
-          </a:fillRef>
-          <a:effectRef idx="2">
-            <a:schemeClr val="accent1"/>
-          </a:effectRef>
-          <a:fontRef idx="minor">
-            <a:schemeClr val="lt1"/>
-          </a:fontRef>
-        </p:style>
-        <p:txBody>
-          <a:bodyPr rtlCol="0" anchor="ctr"/>
-          <a:lstStyle/>
-          <a:p>
-            <a:pPr algn="ctr"/>
-            <a:r>
-              <a:rPr sz="1400" b="0">
-                <a:solidFill>
-                  <a:srgbClr val="444444"/>
-                </a:solidFill>
-              </a:rPr>
-              <a:t>Empty ref</a:t>
-            </a:r>
-          </a:p>
-        </p:txBody>
-      </p:sp>
-      <p:sp>
-        <p:nvSpPr>
-          <p:cNvPr id="11" name="Rectangle 10"/>
-          <p:cNvSpPr/>
-          <p:nvPr/>
-        </p:nvSpPr>
-        <p:spPr>
-          <a:xfrm>
-            <a:off x="2834640" y="1847088"/>
-            <a:ext cx="731520" cy="384048"/>
-          </a:xfrm>
-          <a:prstGeom prst="rect">
-            <a:avLst/>
-          </a:prstGeom>
-          <a:solidFill>
-            <a:srgbClr val="FFFFFF"/>
-          </a:solidFill>
-          <a:ln>
-            <a:solidFill>
-              <a:srgbClr val="1F3864"/>
-            </a:solidFill>
-          </a:ln>
-        </p:spPr>
-        <p:style>
-          <a:lnRef idx="1">
-            <a:schemeClr val="accent1"/>
-          </a:lnRef>
-          <a:fillRef idx="3">
-            <a:schemeClr val="accent1"/>
-          </a:fillRef>
-          <a:effectRef idx="2">
-            <a:schemeClr val="accent1"/>
-          </a:effectRef>
-          <a:fontRef idx="minor">
-            <a:schemeClr val="lt1"/>
-          </a:fontRef>
-        </p:style>
-        <p:txBody>
-          <a:bodyPr rtlCol="0" anchor="ctr"/>
-          <a:lstStyle/>
-          <a:p>
-            <a:pPr algn="ctr"/>
-            <a:r>
-              <a:rPr sz="1400" b="0">
-                <a:solidFill>
-                  <a:srgbClr val="444444"/>
-                </a:solidFill>
-              </a:rPr>
-              <a:t>0</a:t>
-            </a:r>
-          </a:p>
-        </p:txBody>
-      </p:sp>
-      <p:sp>
-        <p:nvSpPr>
-          <p:cNvPr id="12" name="Rectangle 11"/>
-          <p:cNvSpPr/>
-          <p:nvPr/>
-        </p:nvSpPr>
-        <p:spPr>
-          <a:xfrm>
-            <a:off x="3566160" y="1847088"/>
-            <a:ext cx="731520" cy="384048"/>
-          </a:xfrm>
-          <a:prstGeom prst="rect">
-            <a:avLst/>
-          </a:prstGeom>
-          <a:solidFill>
-            <a:srgbClr val="FFFFFF"/>
-          </a:solidFill>
-          <a:ln>
-            <a:solidFill>
-              <a:srgbClr val="1F3864"/>
-            </a:solidFill>
-          </a:ln>
-        </p:spPr>
-        <p:style>
-          <a:lnRef idx="1">
-            <a:schemeClr val="accent1"/>
-          </a:lnRef>
-          <a:fillRef idx="3">
-            <a:schemeClr val="accent1"/>
-          </a:fillRef>
-          <a:effectRef idx="2">
-            <a:schemeClr val="accent1"/>
-          </a:effectRef>
-          <a:fontRef idx="minor">
-            <a:schemeClr val="lt1"/>
-          </a:fontRef>
-        </p:style>
-        <p:txBody>
-          <a:bodyPr rtlCol="0" anchor="ctr"/>
-          <a:lstStyle/>
-          <a:p>
-            <a:pPr algn="ctr"/>
-            <a:r>
-              <a:rPr sz="1400" b="0">
-                <a:solidFill>
-                  <a:srgbClr val="444444"/>
-                </a:solidFill>
-              </a:rPr>
-              <a:t>43</a:t>
-            </a:r>
-          </a:p>
-        </p:txBody>
-      </p:sp>
-      <p:sp>
-        <p:nvSpPr>
-          <p:cNvPr id="13" name="Rectangle 12"/>
-          <p:cNvSpPr/>
-          <p:nvPr/>
-        </p:nvSpPr>
-        <p:spPr>
-          <a:xfrm>
-            <a:off x="4297680" y="1847088"/>
-            <a:ext cx="731520" cy="384048"/>
-          </a:xfrm>
-          <a:prstGeom prst="rect">
-            <a:avLst/>
-          </a:prstGeom>
-          <a:solidFill>
-            <a:srgbClr val="FFFFFF"/>
-          </a:solidFill>
-          <a:ln>
-            <a:solidFill>
-              <a:srgbClr val="1F3864"/>
-            </a:solidFill>
-          </a:ln>
-        </p:spPr>
-        <p:style>
-          <a:lnRef idx="1">
-            <a:schemeClr val="accent1"/>
-          </a:lnRef>
-          <a:fillRef idx="3">
-            <a:schemeClr val="accent1"/>
-          </a:fillRef>
-          <a:effectRef idx="2">
-            <a:schemeClr val="accent1"/>
-          </a:effectRef>
-          <a:fontRef idx="minor">
-            <a:schemeClr val="lt1"/>
-          </a:fontRef>
-        </p:style>
-        <p:txBody>
-          <a:bodyPr rtlCol="0" anchor="ctr"/>
-          <a:lstStyle/>
-          <a:p>
-            <a:pPr algn="ctr"/>
-            <a:r>
-              <a:rPr sz="1400" b="0">
-                <a:solidFill>
-                  <a:srgbClr val="444444"/>
-                </a:solidFill>
-              </a:rPr>
-              <a:t>43</a:t>
-            </a:r>
-          </a:p>
-        </p:txBody>
-      </p:sp>
-      <p:sp>
-        <p:nvSpPr>
-          <p:cNvPr id="14" name="Rectangle 13"/>
-          <p:cNvSpPr/>
-          <p:nvPr/>
-        </p:nvSpPr>
-        <p:spPr>
-          <a:xfrm>
-            <a:off x="365760" y="2231136"/>
-            <a:ext cx="1097280" cy="384048"/>
-          </a:xfrm>
-          <a:prstGeom prst="rect">
-            <a:avLst/>
-          </a:prstGeom>
-          <a:solidFill>
-            <a:srgbClr val="E8F0F8"/>
-          </a:solidFill>
-          <a:ln>
-            <a:solidFill>
-              <a:srgbClr val="1F3864"/>
-            </a:solidFill>
-          </a:ln>
-        </p:spPr>
-        <p:style>
-          <a:lnRef idx="1">
-            <a:schemeClr val="accent1"/>
-          </a:lnRef>
-          <a:fillRef idx="3">
-            <a:schemeClr val="accent1"/>
-          </a:fillRef>
-          <a:effectRef idx="2">
-            <a:schemeClr val="accent1"/>
-          </a:effectRef>
-          <a:fontRef idx="minor">
-            <a:schemeClr val="lt1"/>
-          </a:fontRef>
-        </p:style>
-        <p:txBody>
-          <a:bodyPr rtlCol="0" anchor="ctr"/>
-          <a:lstStyle/>
-          <a:p>
-            <a:pPr algn="ctr"/>
-            <a:r>
-              <a:rPr sz="1400" b="0">
-                <a:solidFill>
-                  <a:srgbClr val="444444"/>
-                </a:solidFill>
-              </a:rPr>
-              <a:t>PUCPR1</a:t>
-            </a:r>
-          </a:p>
-        </p:txBody>
-      </p:sp>
-      <p:sp>
-        <p:nvSpPr>
-          <p:cNvPr id="15" name="Rectangle 14"/>
-          <p:cNvSpPr/>
-          <p:nvPr/>
-        </p:nvSpPr>
-        <p:spPr>
-          <a:xfrm>
-            <a:off x="1463040" y="2231136"/>
-            <a:ext cx="1371600" cy="384048"/>
-          </a:xfrm>
-          <a:prstGeom prst="rect">
-            <a:avLst/>
-          </a:prstGeom>
-          <a:solidFill>
-            <a:srgbClr val="E8F0F8"/>
-          </a:solidFill>
-          <a:ln>
-            <a:solidFill>
-              <a:srgbClr val="1F3864"/>
-            </a:solidFill>
-          </a:ln>
-        </p:spPr>
-        <p:style>
-          <a:lnRef idx="1">
-            <a:schemeClr val="accent1"/>
-          </a:lnRef>
-          <a:fillRef idx="3">
-            <a:schemeClr val="accent1"/>
-          </a:fillRef>
-          <a:effectRef idx="2">
-            <a:schemeClr val="accent1"/>
-          </a:effectRef>
-          <a:fontRef idx="minor">
-            <a:schemeClr val="lt1"/>
-          </a:fontRef>
-        </p:style>
-        <p:txBody>
-          <a:bodyPr rtlCol="0" anchor="ctr"/>
-          <a:lstStyle/>
-          <a:p>
-            <a:pPr algn="ctr"/>
-            <a:r>
-              <a:rPr sz="1400" b="0">
-                <a:solidFill>
-                  <a:srgbClr val="444444"/>
-                </a:solidFill>
-              </a:rPr>
-              <a:t>Partial</a:t>
-            </a:r>
-          </a:p>
-        </p:txBody>
-      </p:sp>
-      <p:sp>
-        <p:nvSpPr>
-          <p:cNvPr id="16" name="Rectangle 15"/>
-          <p:cNvSpPr/>
-          <p:nvPr/>
-        </p:nvSpPr>
-        <p:spPr>
-          <a:xfrm>
-            <a:off x="2834640" y="2231136"/>
-            <a:ext cx="731520" cy="384048"/>
-          </a:xfrm>
-          <a:prstGeom prst="rect">
-            <a:avLst/>
-          </a:prstGeom>
-          <a:solidFill>
-            <a:srgbClr val="E8F0F8"/>
-          </a:solidFill>
-          <a:ln>
-            <a:solidFill>
-              <a:srgbClr val="1F3864"/>
-            </a:solidFill>
-          </a:ln>
-        </p:spPr>
-        <p:style>
-          <a:lnRef idx="1">
-            <a:schemeClr val="accent1"/>
-          </a:lnRef>
-          <a:fillRef idx="3">
-            <a:schemeClr val="accent1"/>
-          </a:fillRef>
-          <a:effectRef idx="2">
-            <a:schemeClr val="accent1"/>
-          </a:effectRef>
-          <a:fontRef idx="minor">
-            <a:schemeClr val="lt1"/>
-          </a:fontRef>
-        </p:style>
-        <p:txBody>
-          <a:bodyPr rtlCol="0" anchor="ctr"/>
-          <a:lstStyle/>
-          <a:p>
-            <a:pPr algn="ctr"/>
-            <a:r>
-              <a:rPr sz="1400" b="0">
-                <a:solidFill>
-                  <a:srgbClr val="444444"/>
-                </a:solidFill>
-              </a:rPr>
-              <a:t>26</a:t>
-            </a:r>
-          </a:p>
-        </p:txBody>
-      </p:sp>
-      <p:sp>
-        <p:nvSpPr>
-          <p:cNvPr id="17" name="Rectangle 16"/>
-          <p:cNvSpPr/>
-          <p:nvPr/>
-        </p:nvSpPr>
-        <p:spPr>
-          <a:xfrm>
-            <a:off x="3566160" y="2231136"/>
-            <a:ext cx="731520" cy="384048"/>
-          </a:xfrm>
-          <a:prstGeom prst="rect">
-            <a:avLst/>
-          </a:prstGeom>
-          <a:solidFill>
-            <a:srgbClr val="E8F0F8"/>
-          </a:solidFill>
-          <a:ln>
-            <a:solidFill>
-              <a:srgbClr val="1F3864"/>
-            </a:solidFill>
-          </a:ln>
-        </p:spPr>
-        <p:style>
-          <a:lnRef idx="1">
-            <a:schemeClr val="accent1"/>
-          </a:lnRef>
-          <a:fillRef idx="3">
-            <a:schemeClr val="accent1"/>
-          </a:fillRef>
-          <a:effectRef idx="2">
-            <a:schemeClr val="accent1"/>
-          </a:effectRef>
-          <a:fontRef idx="minor">
-            <a:schemeClr val="lt1"/>
-          </a:fontRef>
-        </p:style>
-        <p:txBody>
-          <a:bodyPr rtlCol="0" anchor="ctr"/>
-          <a:lstStyle/>
-          <a:p>
-            <a:pPr algn="ctr"/>
-            <a:r>
-              <a:rPr sz="1400" b="0">
-                <a:solidFill>
-                  <a:srgbClr val="444444"/>
-                </a:solidFill>
-              </a:rPr>
-              <a:t>17</a:t>
-            </a:r>
-          </a:p>
-        </p:txBody>
-      </p:sp>
-      <p:sp>
-        <p:nvSpPr>
-          <p:cNvPr id="18" name="Rectangle 17"/>
-          <p:cNvSpPr/>
-          <p:nvPr/>
-        </p:nvSpPr>
-        <p:spPr>
-          <a:xfrm>
-            <a:off x="4297680" y="2231136"/>
-            <a:ext cx="731520" cy="384048"/>
-          </a:xfrm>
-          <a:prstGeom prst="rect">
-            <a:avLst/>
-          </a:prstGeom>
-          <a:solidFill>
-            <a:srgbClr val="E8F0F8"/>
-          </a:solidFill>
-          <a:ln>
-            <a:solidFill>
-              <a:srgbClr val="1F3864"/>
-            </a:solidFill>
-          </a:ln>
-        </p:spPr>
-        <p:style>
-          <a:lnRef idx="1">
-            <a:schemeClr val="accent1"/>
-          </a:lnRef>
-          <a:fillRef idx="3">
-            <a:schemeClr val="accent1"/>
-          </a:fillRef>
-          <a:effectRef idx="2">
-            <a:schemeClr val="accent1"/>
-          </a:effectRef>
-          <a:fontRef idx="minor">
-            <a:schemeClr val="lt1"/>
-          </a:fontRef>
-        </p:style>
-        <p:txBody>
-          <a:bodyPr rtlCol="0" anchor="ctr"/>
-          <a:lstStyle/>
-          <a:p>
-            <a:pPr algn="ctr"/>
-            <a:r>
-              <a:rPr sz="1400" b="0">
-                <a:solidFill>
-                  <a:srgbClr val="444444"/>
-                </a:solidFill>
-              </a:rPr>
-              <a:t>43</a:t>
-            </a:r>
-          </a:p>
-        </p:txBody>
-      </p:sp>
-      <p:sp>
-        <p:nvSpPr>
-          <p:cNvPr id="19" name="Rectangle 18"/>
-          <p:cNvSpPr/>
-          <p:nvPr/>
-        </p:nvSpPr>
-        <p:spPr>
-          <a:xfrm>
-            <a:off x="365760" y="2615184"/>
-            <a:ext cx="1097280" cy="384048"/>
-          </a:xfrm>
-          <a:prstGeom prst="rect">
-            <a:avLst/>
-          </a:prstGeom>
-          <a:solidFill>
-            <a:srgbClr val="FFFFFF"/>
-          </a:solidFill>
-          <a:ln>
-            <a:solidFill>
-              <a:srgbClr val="1F3864"/>
-            </a:solidFill>
-          </a:ln>
-        </p:spPr>
-        <p:style>
-          <a:lnRef idx="1">
-            <a:schemeClr val="accent1"/>
-          </a:lnRef>
-          <a:fillRef idx="3">
-            <a:schemeClr val="accent1"/>
-          </a:fillRef>
-          <a:effectRef idx="2">
-            <a:schemeClr val="accent1"/>
-          </a:effectRef>
-          <a:fontRef idx="minor">
-            <a:schemeClr val="lt1"/>
-          </a:fontRef>
-        </p:style>
-        <p:txBody>
-          <a:bodyPr rtlCol="0" anchor="ctr"/>
-          <a:lstStyle/>
-          <a:p>
-            <a:pPr algn="ctr"/>
-            <a:r>
-              <a:rPr sz="1400" b="0">
-                <a:solidFill>
-                  <a:srgbClr val="444444"/>
-                </a:solidFill>
-              </a:rPr>
-              <a:t>PUCPR2</a:t>
-            </a:r>
-          </a:p>
-        </p:txBody>
-      </p:sp>
-      <p:sp>
-        <p:nvSpPr>
-          <p:cNvPr id="20" name="Rectangle 19"/>
-          <p:cNvSpPr/>
-          <p:nvPr/>
-        </p:nvSpPr>
-        <p:spPr>
-          <a:xfrm>
-            <a:off x="1463040" y="2615184"/>
-            <a:ext cx="1371600" cy="384048"/>
-          </a:xfrm>
-          <a:prstGeom prst="rect">
-            <a:avLst/>
-          </a:prstGeom>
-          <a:solidFill>
-            <a:srgbClr val="FFFFFF"/>
-          </a:solidFill>
-          <a:ln>
-            <a:solidFill>
-              <a:srgbClr val="1F3864"/>
-            </a:solidFill>
-          </a:ln>
-        </p:spPr>
-        <p:style>
-          <a:lnRef idx="1">
-            <a:schemeClr val="accent1"/>
-          </a:lnRef>
-          <a:fillRef idx="3">
-            <a:schemeClr val="accent1"/>
-          </a:fillRef>
-          <a:effectRef idx="2">
-            <a:schemeClr val="accent1"/>
-          </a:effectRef>
-          <a:fontRef idx="minor">
-            <a:schemeClr val="lt1"/>
-          </a:fontRef>
-        </p:style>
-        <p:txBody>
-          <a:bodyPr rtlCol="0" anchor="ctr"/>
-          <a:lstStyle/>
-          <a:p>
-            <a:pPr algn="ctr"/>
-            <a:r>
-              <a:rPr sz="1400" b="0">
-                <a:solidFill>
-                  <a:srgbClr val="444444"/>
-                </a:solidFill>
-              </a:rPr>
-              <a:t>Heavy</a:t>
-            </a:r>
-          </a:p>
-        </p:txBody>
-      </p:sp>
-      <p:sp>
-        <p:nvSpPr>
-          <p:cNvPr id="21" name="Rectangle 20"/>
-          <p:cNvSpPr/>
-          <p:nvPr/>
-        </p:nvSpPr>
-        <p:spPr>
-          <a:xfrm>
-            <a:off x="2834640" y="2615184"/>
-            <a:ext cx="731520" cy="384048"/>
-          </a:xfrm>
-          <a:prstGeom prst="rect">
-            <a:avLst/>
-          </a:prstGeom>
-          <a:solidFill>
-            <a:srgbClr val="FFFFFF"/>
-          </a:solidFill>
-          <a:ln>
-            <a:solidFill>
-              <a:srgbClr val="1F3864"/>
-            </a:solidFill>
-          </a:ln>
-        </p:spPr>
-        <p:style>
-          <a:lnRef idx="1">
-            <a:schemeClr val="accent1"/>
-          </a:lnRef>
-          <a:fillRef idx="3">
-            <a:schemeClr val="accent1"/>
-          </a:fillRef>
-          <a:effectRef idx="2">
-            <a:schemeClr val="accent1"/>
-          </a:effectRef>
-          <a:fontRef idx="minor">
-            <a:schemeClr val="lt1"/>
-          </a:fontRef>
-        </p:style>
-        <p:txBody>
-          <a:bodyPr rtlCol="0" anchor="ctr"/>
-          <a:lstStyle/>
-          <a:p>
-            <a:pPr algn="ctr"/>
-            <a:r>
-              <a:rPr sz="1400" b="0">
-                <a:solidFill>
-                  <a:srgbClr val="444444"/>
-                </a:solidFill>
-              </a:rPr>
-              <a:t>32</a:t>
-            </a:r>
-          </a:p>
-        </p:txBody>
-      </p:sp>
-      <p:sp>
-        <p:nvSpPr>
-          <p:cNvPr id="22" name="Rectangle 21"/>
-          <p:cNvSpPr/>
-          <p:nvPr/>
-        </p:nvSpPr>
-        <p:spPr>
-          <a:xfrm>
-            <a:off x="3566160" y="2615184"/>
-            <a:ext cx="731520" cy="384048"/>
-          </a:xfrm>
-          <a:prstGeom prst="rect">
-            <a:avLst/>
-          </a:prstGeom>
-          <a:solidFill>
-            <a:srgbClr val="FFFFFF"/>
-          </a:solidFill>
-          <a:ln>
-            <a:solidFill>
-              <a:srgbClr val="1F3864"/>
-            </a:solidFill>
-          </a:ln>
-        </p:spPr>
-        <p:style>
-          <a:lnRef idx="1">
-            <a:schemeClr val="accent1"/>
-          </a:lnRef>
-          <a:fillRef idx="3">
-            <a:schemeClr val="accent1"/>
-          </a:fillRef>
-          <a:effectRef idx="2">
-            <a:schemeClr val="accent1"/>
-          </a:effectRef>
-          <a:fontRef idx="minor">
-            <a:schemeClr val="lt1"/>
-          </a:fontRef>
-        </p:style>
-        <p:txBody>
-          <a:bodyPr rtlCol="0" anchor="ctr"/>
-          <a:lstStyle/>
-          <a:p>
-            <a:pPr algn="ctr"/>
-            <a:r>
-              <a:rPr sz="1400" b="0">
-                <a:solidFill>
-                  <a:srgbClr val="444444"/>
-                </a:solidFill>
-              </a:rPr>
-              <a:t>11</a:t>
-            </a:r>
-          </a:p>
-        </p:txBody>
-      </p:sp>
-      <p:sp>
-        <p:nvSpPr>
-          <p:cNvPr id="23" name="Rectangle 22"/>
-          <p:cNvSpPr/>
-          <p:nvPr/>
-        </p:nvSpPr>
-        <p:spPr>
-          <a:xfrm>
-            <a:off x="4297680" y="2615184"/>
-            <a:ext cx="731520" cy="384048"/>
-          </a:xfrm>
-          <a:prstGeom prst="rect">
-            <a:avLst/>
-          </a:prstGeom>
-          <a:solidFill>
-            <a:srgbClr val="FFFFFF"/>
-          </a:solidFill>
-          <a:ln>
-            <a:solidFill>
-              <a:srgbClr val="1F3864"/>
-            </a:solidFill>
-          </a:ln>
-        </p:spPr>
-        <p:style>
-          <a:lnRef idx="1">
-            <a:schemeClr val="accent1"/>
-          </a:lnRef>
-          <a:fillRef idx="3">
-            <a:schemeClr val="accent1"/>
-          </a:fillRef>
-          <a:effectRef idx="2">
-            <a:schemeClr val="accent1"/>
-          </a:effectRef>
-          <a:fontRef idx="minor">
-            <a:schemeClr val="lt1"/>
-          </a:fontRef>
-        </p:style>
-        <p:txBody>
-          <a:bodyPr rtlCol="0" anchor="ctr"/>
-          <a:lstStyle/>
-          <a:p>
-            <a:pPr algn="ctr"/>
-            <a:r>
-              <a:rPr sz="1400" b="0">
-                <a:solidFill>
-                  <a:srgbClr val="444444"/>
-                </a:solidFill>
-              </a:rPr>
-              <a:t>43</a:t>
-            </a:r>
-          </a:p>
-        </p:txBody>
-      </p:sp>
-      <p:sp>
-        <p:nvSpPr>
-          <p:cNvPr id="24" name="Rectangle 23"/>
-          <p:cNvSpPr/>
-          <p:nvPr/>
-        </p:nvSpPr>
-        <p:spPr>
-          <a:xfrm>
-            <a:off x="0" y="0"/>
-            <a:ext cx="12188952" cy="1280160"/>
-          </a:xfrm>
-          <a:prstGeom prst="rect">
-            <a:avLst/>
-          </a:prstGeom>
-          <a:solidFill>
-            <a:srgbClr val="1F3864"/>
-          </a:solidFill>
-          <a:ln>
-            <a:noFill/>
-          </a:ln>
-        </p:spPr>
-        <p:style>
-          <a:lnRef idx="1">
-            <a:schemeClr val="accent1"/>
-          </a:lnRef>
-          <a:fillRef idx="3">
-            <a:schemeClr val="accent1"/>
-          </a:fillRef>
-          <a:effectRef idx="2">
-            <a:schemeClr val="accent1"/>
-          </a:effectRef>
-          <a:fontRef idx="minor">
-            <a:schemeClr val="lt1"/>
-          </a:fontRef>
-        </p:style>
-        <p:txBody>
-          <a:bodyPr rtlCol="0" anchor="ctr"/>
-          <a:lstStyle/>
-          <a:p>
-            <a:pPr algn="ctr"/>
-          </a:p>
-        </p:txBody>
-      </p:sp>
-      <p:sp>
-        <p:nvSpPr>
-          <p:cNvPr id="25" name="TextBox 24"/>
+              <a:t>Result — UFPR04 (Empty Lot)</a:t>
+            </a:r>
+          </a:p>
+        </p:txBody>
+      </p:sp>
+      <p:pic>
+        <p:nvPicPr>
+          <p:cNvPr id="4" name="Picture 3" descr="result_UFPR1.jpg"/>
+          <p:cNvPicPr>
+            <a:picLocks noChangeAspect="1"/>
+          </p:cNvPicPr>
+          <p:nvPr/>
+        </p:nvPicPr>
+        <p:blipFill>
+          <a:blip r:embed="rId2"/>
+          <a:stretch>
+            <a:fillRect/>
+          </a:stretch>
+        </p:blipFill>
+        <p:spPr>
+          <a:xfrm>
+            <a:off x="2286000" y="1371600"/>
+            <a:ext cx="7315200" cy="4846320"/>
+          </a:xfrm>
+          <a:prstGeom prst="rect">
+            <a:avLst/>
+          </a:prstGeom>
+        </p:spPr>
+      </p:pic>
+      <p:sp>
+        <p:nvSpPr>
+          <p:cNvPr id="5" name="TextBox 4"/>
           <p:cNvSpPr txBox="1"/>
           <p:nvPr/>
         </p:nvSpPr>
         <p:spPr>
           <a:xfrm>
-            <a:off x="274320" y="91440"/>
-            <a:ext cx="11612880" cy="731520"/>
+            <a:off x="274320" y="6309360"/>
+            <a:ext cx="11612880" cy="457200"/>
           </a:xfrm>
           <a:prstGeom prst="rect">
             <a:avLst/>
@@ -7059,150 +8789,14 @@
           </a:bodyPr>
           <a:lstStyle/>
           <a:p>
-            <a:pPr algn="l"/>
-            <a:r>
-              <a:rPr sz="3200" b="1">
-                <a:solidFill>
-                  <a:srgbClr val="FFFFFF"/>
-                </a:solidFill>
-              </a:rPr>
-              <a:t/>
-            </a:r>
-          </a:p>
-        </p:txBody>
-      </p:sp>
-      <p:sp>
-        <p:nvSpPr>
-          <p:cNvPr id="26" name="TextBox 25"/>
-          <p:cNvSpPr txBox="1"/>
-          <p:nvPr/>
-        </p:nvSpPr>
-        <p:spPr>
-          <a:xfrm>
-            <a:off x="365760" y="3291840"/>
-            <a:ext cx="11430000" cy="502920"/>
-          </a:xfrm>
-          <a:prstGeom prst="rect">
-            <a:avLst/>
-          </a:prstGeom>
-          <a:noFill/>
-        </p:spPr>
-        <p:txBody>
-          <a:bodyPr wrap="square">
-            <a:spAutoFit/>
-          </a:bodyPr>
-          <a:lstStyle/>
-          <a:p>
-            <a:pPr algn="l"/>
-            <a:r>
-              <a:rPr sz="2000" b="0">
+            <a:pPr algn="ctr"/>
+            <a:r>
+              <a:rPr sz="1600" b="0">
                 <a:solidFill>
                   <a:srgbClr val="444444"/>
                 </a:solidFill>
               </a:rPr>
-              <a:t>  • Fundamental challenge: edge/σ distributions of empty textured spaces and low-contrast cars overlap</a:t>
-            </a:r>
-          </a:p>
-        </p:txBody>
-      </p:sp>
-      <p:sp>
-        <p:nvSpPr>
-          <p:cNvPr id="27" name="TextBox 26"/>
-          <p:cNvSpPr txBox="1"/>
-          <p:nvPr/>
-        </p:nvSpPr>
-        <p:spPr>
-          <a:xfrm>
-            <a:off x="365760" y="3822192"/>
-            <a:ext cx="11430000" cy="502920"/>
-          </a:xfrm>
-          <a:prstGeom prst="rect">
-            <a:avLst/>
-          </a:prstGeom>
-          <a:noFill/>
-        </p:spPr>
-        <p:txBody>
-          <a:bodyPr wrap="square">
-            <a:spAutoFit/>
-          </a:bodyPr>
-          <a:lstStyle/>
-          <a:p>
-            <a:pPr algn="l"/>
-            <a:r>
-              <a:rPr sz="2000" b="0">
-                <a:solidFill>
-                  <a:srgbClr val="444444"/>
-                </a:solidFill>
-              </a:rPr>
-              <a:t>  • Canny(30,90) tested — empty-space max rose from 127→234, requiring threshold 244 (too high)</a:t>
-            </a:r>
-          </a:p>
-        </p:txBody>
-      </p:sp>
-      <p:sp>
-        <p:nvSpPr>
-          <p:cNvPr id="28" name="TextBox 27"/>
-          <p:cNvSpPr txBox="1"/>
-          <p:nvPr/>
-        </p:nvSpPr>
-        <p:spPr>
-          <a:xfrm>
-            <a:off x="365760" y="4352544"/>
-            <a:ext cx="11430000" cy="502920"/>
-          </a:xfrm>
-          <a:prstGeom prst="rect">
-            <a:avLst/>
-          </a:prstGeom>
-          <a:noFill/>
-        </p:spPr>
-        <p:txBody>
-          <a:bodyPr wrap="square">
-            <a:spAutoFit/>
-          </a:bodyPr>
-          <a:lstStyle/>
-          <a:p>
-            <a:pPr algn="l"/>
-            <a:r>
-              <a:rPr sz="2000" b="0">
-                <a:solidFill>
-                  <a:srgbClr val="444444"/>
-                </a:solidFill>
-              </a:rPr>
-              <a:t>  • Dual-signal OR logic improves recall without increasing false positives on calibration image</a:t>
-            </a:r>
-          </a:p>
-        </p:txBody>
-      </p:sp>
-      <p:sp>
-        <p:nvSpPr>
-          <p:cNvPr id="29" name="TextBox 28"/>
-          <p:cNvSpPr txBox="1"/>
-          <p:nvPr/>
-        </p:nvSpPr>
-        <p:spPr>
-          <a:xfrm>
-            <a:off x="365760" y="4882896"/>
-            <a:ext cx="11430000" cy="502920"/>
-          </a:xfrm>
-          <a:prstGeom prst="rect">
-            <a:avLst/>
-          </a:prstGeom>
-          <a:noFill/>
-        </p:spPr>
-        <p:txBody>
-          <a:bodyPr wrap="square">
-            <a:spAutoFit/>
-          </a:bodyPr>
-          <a:lstStyle/>
-          <a:p>
-            <a:pPr algn="l"/>
-            <a:r>
-              <a:rPr sz="2000" b="0">
-                <a:solidFill>
-                  <a:srgbClr val="444444"/>
-                </a:solidFill>
-              </a:rPr>
-              <a:t>  • Remaining errors are irreducible without a background reference or learned classifier</a:t>
+              <a:t>UFPR1.jpg  |  Detected: 0 Occupied  /  257 Empty  |  Zero false positives on calibration image</a:t>
             </a:r>
           </a:p>
         </p:txBody>

</xml_diff>

<commit_message>
slight template change for docs
</commit_message>
<xml_diff>
--- a/docs/slides.pptx
+++ b/docs/slides.pptx
@@ -7992,7 +7992,7 @@
                   <a:srgbClr val="444444"/>
                 </a:solidFill>
               </a:rPr>
-              <a:t>  • Dataset: PKLot — overhead images from PUCPR and UFPR04 (Brazil) under varied lighting and occupancy conditions</a:t>
+              <a:t>  • Dataset: PKLot (PUCPR + UFPR04) plus a third lot (ANG) — overhead images under varied lighting and occupancy conditions</a:t>
             </a:r>
           </a:p>
         </p:txBody>
@@ -9396,7 +9396,7 @@
                   <a:srgbClr val="FFFFFF"/>
                 </a:solidFill>
               </a:rPr>
-              <a:t>ROI Definition — Both Lots</a:t>
+              <a:t>ROI Definition — All Three Lots</a:t>
             </a:r>
           </a:p>
         </p:txBody>

</xml_diff>